<commit_message>
Atualizacao conforme instrucoes do professor
</commit_message>
<xml_diff>
--- a/NFS/Sprint2.pptx
+++ b/NFS/Sprint2.pptx
@@ -7,9 +7,10 @@
   <p:sldIdLst>
     <p:sldId id="256" r:id="rId2"/>
     <p:sldId id="257" r:id="rId3"/>
+    <p:sldId id="258" r:id="rId4"/>
   </p:sldIdLst>
   <p:sldSz cx="12192000" cy="6858000"/>
-  <p:notesSz cx="6858000" cy="9144000"/>
+  <p:notesSz cx="6858000" cy="9947275"/>
   <p:defaultTextStyle>
     <a:defPPr>
       <a:defRPr lang="pt-BR"/>
@@ -260,7 +261,7 @@
           <a:p>
             <a:fld id="{820491FF-F0B0-49E5-BF78-782B62461F8E}" type="datetimeFigureOut">
               <a:rPr lang="pt-BR" smtClean="0"/>
-              <a:t>21/10/2024</a:t>
+              <a:t>28/10/2024</a:t>
             </a:fld>
             <a:endParaRPr lang="pt-BR"/>
           </a:p>
@@ -458,7 +459,7 @@
           <a:p>
             <a:fld id="{820491FF-F0B0-49E5-BF78-782B62461F8E}" type="datetimeFigureOut">
               <a:rPr lang="pt-BR" smtClean="0"/>
-              <a:t>21/10/2024</a:t>
+              <a:t>28/10/2024</a:t>
             </a:fld>
             <a:endParaRPr lang="pt-BR"/>
           </a:p>
@@ -666,7 +667,7 @@
           <a:p>
             <a:fld id="{820491FF-F0B0-49E5-BF78-782B62461F8E}" type="datetimeFigureOut">
               <a:rPr lang="pt-BR" smtClean="0"/>
-              <a:t>21/10/2024</a:t>
+              <a:t>28/10/2024</a:t>
             </a:fld>
             <a:endParaRPr lang="pt-BR"/>
           </a:p>
@@ -864,7 +865,7 @@
           <a:p>
             <a:fld id="{820491FF-F0B0-49E5-BF78-782B62461F8E}" type="datetimeFigureOut">
               <a:rPr lang="pt-BR" smtClean="0"/>
-              <a:t>21/10/2024</a:t>
+              <a:t>28/10/2024</a:t>
             </a:fld>
             <a:endParaRPr lang="pt-BR"/>
           </a:p>
@@ -1139,7 +1140,7 @@
           <a:p>
             <a:fld id="{820491FF-F0B0-49E5-BF78-782B62461F8E}" type="datetimeFigureOut">
               <a:rPr lang="pt-BR" smtClean="0"/>
-              <a:t>21/10/2024</a:t>
+              <a:t>28/10/2024</a:t>
             </a:fld>
             <a:endParaRPr lang="pt-BR"/>
           </a:p>
@@ -1404,7 +1405,7 @@
           <a:p>
             <a:fld id="{820491FF-F0B0-49E5-BF78-782B62461F8E}" type="datetimeFigureOut">
               <a:rPr lang="pt-BR" smtClean="0"/>
-              <a:t>21/10/2024</a:t>
+              <a:t>28/10/2024</a:t>
             </a:fld>
             <a:endParaRPr lang="pt-BR"/>
           </a:p>
@@ -1816,7 +1817,7 @@
           <a:p>
             <a:fld id="{820491FF-F0B0-49E5-BF78-782B62461F8E}" type="datetimeFigureOut">
               <a:rPr lang="pt-BR" smtClean="0"/>
-              <a:t>21/10/2024</a:t>
+              <a:t>28/10/2024</a:t>
             </a:fld>
             <a:endParaRPr lang="pt-BR"/>
           </a:p>
@@ -1957,7 +1958,7 @@
           <a:p>
             <a:fld id="{820491FF-F0B0-49E5-BF78-782B62461F8E}" type="datetimeFigureOut">
               <a:rPr lang="pt-BR" smtClean="0"/>
-              <a:t>21/10/2024</a:t>
+              <a:t>28/10/2024</a:t>
             </a:fld>
             <a:endParaRPr lang="pt-BR"/>
           </a:p>
@@ -2070,7 +2071,7 @@
           <a:p>
             <a:fld id="{820491FF-F0B0-49E5-BF78-782B62461F8E}" type="datetimeFigureOut">
               <a:rPr lang="pt-BR" smtClean="0"/>
-              <a:t>21/10/2024</a:t>
+              <a:t>28/10/2024</a:t>
             </a:fld>
             <a:endParaRPr lang="pt-BR"/>
           </a:p>
@@ -2381,7 +2382,7 @@
           <a:p>
             <a:fld id="{820491FF-F0B0-49E5-BF78-782B62461F8E}" type="datetimeFigureOut">
               <a:rPr lang="pt-BR" smtClean="0"/>
-              <a:t>21/10/2024</a:t>
+              <a:t>28/10/2024</a:t>
             </a:fld>
             <a:endParaRPr lang="pt-BR"/>
           </a:p>
@@ -2669,7 +2670,7 @@
           <a:p>
             <a:fld id="{820491FF-F0B0-49E5-BF78-782B62461F8E}" type="datetimeFigureOut">
               <a:rPr lang="pt-BR" smtClean="0"/>
-              <a:t>21/10/2024</a:t>
+              <a:t>28/10/2024</a:t>
             </a:fld>
             <a:endParaRPr lang="pt-BR"/>
           </a:p>
@@ -2910,7 +2911,7 @@
           <a:p>
             <a:fld id="{820491FF-F0B0-49E5-BF78-782B62461F8E}" type="datetimeFigureOut">
               <a:rPr lang="pt-BR" smtClean="0"/>
-              <a:t>21/10/2024</a:t>
+              <a:t>28/10/2024</a:t>
             </a:fld>
             <a:endParaRPr lang="pt-BR"/>
           </a:p>
@@ -6012,94 +6013,6 @@
           <a:chExt cx="0" cy="0"/>
         </a:xfrm>
       </p:grpSpPr>
-      <p:sp>
-        <p:nvSpPr>
-          <p:cNvPr id="51" name="CaixaDeTexto 50">
-            <a:extLst>
-              <a:ext uri="{FF2B5EF4-FFF2-40B4-BE49-F238E27FC236}">
-                <a16:creationId xmlns:a16="http://schemas.microsoft.com/office/drawing/2014/main" id="{59AAE7CE-07AF-4628-8F24-5EBEBF57E4B4}"/>
-              </a:ext>
-            </a:extLst>
-          </p:cNvPr>
-          <p:cNvSpPr txBox="1"/>
-          <p:nvPr/>
-        </p:nvSpPr>
-        <p:spPr>
-          <a:xfrm>
-            <a:off x="5982730" y="6525457"/>
-            <a:ext cx="1600118" cy="288541"/>
-          </a:xfrm>
-          <a:prstGeom prst="rect">
-            <a:avLst/>
-          </a:prstGeom>
-          <a:noFill/>
-        </p:spPr>
-        <p:txBody>
-          <a:bodyPr wrap="none" rtlCol="0">
-            <a:spAutoFit/>
-          </a:bodyPr>
-          <a:lstStyle/>
-          <a:p>
-            <a:pPr algn="ctr"/>
-            <a:r>
-              <a:rPr lang="pt-BR" sz="1275" spc="0" baseline="0" dirty="0">
-                <a:solidFill>
-                  <a:srgbClr val="4D4D4D"/>
-                </a:solidFill>
-                <a:latin typeface="Arial"/>
-                <a:cs typeface="Arial"/>
-                <a:sym typeface="Arial"/>
-                <a:rtl val="0"/>
-              </a:rPr>
-              <a:t>FF:FF:0A:0A:00:0C</a:t>
-            </a:r>
-          </a:p>
-        </p:txBody>
-      </p:sp>
-      <p:sp>
-        <p:nvSpPr>
-          <p:cNvPr id="52" name="CaixaDeTexto 51">
-            <a:extLst>
-              <a:ext uri="{FF2B5EF4-FFF2-40B4-BE49-F238E27FC236}">
-                <a16:creationId xmlns:a16="http://schemas.microsoft.com/office/drawing/2014/main" id="{4291983A-7550-43C9-BDE1-ABDC7B31DA75}"/>
-              </a:ext>
-            </a:extLst>
-          </p:cNvPr>
-          <p:cNvSpPr txBox="1"/>
-          <p:nvPr/>
-        </p:nvSpPr>
-        <p:spPr>
-          <a:xfrm>
-            <a:off x="6297999" y="6304763"/>
-            <a:ext cx="958917" cy="288541"/>
-          </a:xfrm>
-          <a:prstGeom prst="rect">
-            <a:avLst/>
-          </a:prstGeom>
-          <a:noFill/>
-        </p:spPr>
-        <p:txBody>
-          <a:bodyPr wrap="none" rtlCol="0">
-            <a:spAutoFit/>
-          </a:bodyPr>
-          <a:lstStyle/>
-          <a:p>
-            <a:pPr algn="ctr"/>
-            <a:r>
-              <a:rPr lang="pt-BR" sz="1275" spc="0" baseline="0" dirty="0">
-                <a:solidFill>
-                  <a:srgbClr val="4D4D4D"/>
-                </a:solidFill>
-                <a:latin typeface="Arial"/>
-                <a:cs typeface="Arial"/>
-                <a:sym typeface="Arial"/>
-                <a:rtl val="0"/>
-              </a:rPr>
-              <a:t>10.10.0.12</a:t>
-            </a:r>
-          </a:p>
-        </p:txBody>
-      </p:sp>
       <p:pic>
         <p:nvPicPr>
           <p:cNvPr id="2" name="Imagem 1">
@@ -6130,94 +6043,6 @@
           </a:prstGeom>
         </p:spPr>
       </p:pic>
-      <p:sp>
-        <p:nvSpPr>
-          <p:cNvPr id="79" name="CaixaDeTexto 78">
-            <a:extLst>
-              <a:ext uri="{FF2B5EF4-FFF2-40B4-BE49-F238E27FC236}">
-                <a16:creationId xmlns:a16="http://schemas.microsoft.com/office/drawing/2014/main" id="{2F8F3D7D-BC3C-4E78-AB32-07297721FB64}"/>
-              </a:ext>
-            </a:extLst>
-          </p:cNvPr>
-          <p:cNvSpPr txBox="1"/>
-          <p:nvPr/>
-        </p:nvSpPr>
-        <p:spPr>
-          <a:xfrm>
-            <a:off x="4055162" y="6525457"/>
-            <a:ext cx="1590500" cy="288541"/>
-          </a:xfrm>
-          <a:prstGeom prst="rect">
-            <a:avLst/>
-          </a:prstGeom>
-          <a:noFill/>
-        </p:spPr>
-        <p:txBody>
-          <a:bodyPr wrap="none" rtlCol="0">
-            <a:spAutoFit/>
-          </a:bodyPr>
-          <a:lstStyle/>
-          <a:p>
-            <a:pPr algn="ctr"/>
-            <a:r>
-              <a:rPr lang="pt-BR" sz="1275" spc="0" baseline="0" dirty="0">
-                <a:solidFill>
-                  <a:srgbClr val="4D4D4D"/>
-                </a:solidFill>
-                <a:latin typeface="Arial"/>
-                <a:cs typeface="Arial"/>
-                <a:sym typeface="Arial"/>
-                <a:rtl val="0"/>
-              </a:rPr>
-              <a:t>FF:FF:0A:0A:00:0B</a:t>
-            </a:r>
-          </a:p>
-        </p:txBody>
-      </p:sp>
-      <p:sp>
-        <p:nvSpPr>
-          <p:cNvPr id="80" name="CaixaDeTexto 79">
-            <a:extLst>
-              <a:ext uri="{FF2B5EF4-FFF2-40B4-BE49-F238E27FC236}">
-                <a16:creationId xmlns:a16="http://schemas.microsoft.com/office/drawing/2014/main" id="{ACB4CDA4-8637-4477-B694-E946B538D626}"/>
-              </a:ext>
-            </a:extLst>
-          </p:cNvPr>
-          <p:cNvSpPr txBox="1"/>
-          <p:nvPr/>
-        </p:nvSpPr>
-        <p:spPr>
-          <a:xfrm>
-            <a:off x="4371681" y="6304763"/>
-            <a:ext cx="946799" cy="288541"/>
-          </a:xfrm>
-          <a:prstGeom prst="rect">
-            <a:avLst/>
-          </a:prstGeom>
-          <a:noFill/>
-        </p:spPr>
-        <p:txBody>
-          <a:bodyPr wrap="none" rtlCol="0">
-            <a:spAutoFit/>
-          </a:bodyPr>
-          <a:lstStyle/>
-          <a:p>
-            <a:pPr algn="ctr"/>
-            <a:r>
-              <a:rPr lang="pt-BR" sz="1275" spc="0" baseline="0" dirty="0">
-                <a:solidFill>
-                  <a:srgbClr val="4D4D4D"/>
-                </a:solidFill>
-                <a:latin typeface="Arial"/>
-                <a:cs typeface="Arial"/>
-                <a:sym typeface="Arial"/>
-                <a:rtl val="0"/>
-              </a:rPr>
-              <a:t>10.10.0.11</a:t>
-            </a:r>
-          </a:p>
-        </p:txBody>
-      </p:sp>
       <p:pic>
         <p:nvPicPr>
           <p:cNvPr id="81" name="Imagem 80">
@@ -6248,94 +6073,6 @@
           </a:prstGeom>
         </p:spPr>
       </p:pic>
-      <p:sp>
-        <p:nvSpPr>
-          <p:cNvPr id="82" name="CaixaDeTexto 81">
-            <a:extLst>
-              <a:ext uri="{FF2B5EF4-FFF2-40B4-BE49-F238E27FC236}">
-                <a16:creationId xmlns:a16="http://schemas.microsoft.com/office/drawing/2014/main" id="{C5FE19BE-F011-4EA0-8625-0757B15D275F}"/>
-              </a:ext>
-            </a:extLst>
-          </p:cNvPr>
-          <p:cNvSpPr txBox="1"/>
-          <p:nvPr/>
-        </p:nvSpPr>
-        <p:spPr>
-          <a:xfrm>
-            <a:off x="2122786" y="6525457"/>
-            <a:ext cx="1590500" cy="288541"/>
-          </a:xfrm>
-          <a:prstGeom prst="rect">
-            <a:avLst/>
-          </a:prstGeom>
-          <a:noFill/>
-        </p:spPr>
-        <p:txBody>
-          <a:bodyPr wrap="none" rtlCol="0">
-            <a:spAutoFit/>
-          </a:bodyPr>
-          <a:lstStyle/>
-          <a:p>
-            <a:pPr algn="ctr"/>
-            <a:r>
-              <a:rPr lang="pt-BR" sz="1275" spc="0" baseline="0" dirty="0">
-                <a:solidFill>
-                  <a:srgbClr val="4D4D4D"/>
-                </a:solidFill>
-                <a:latin typeface="Arial"/>
-                <a:cs typeface="Arial"/>
-                <a:sym typeface="Arial"/>
-                <a:rtl val="0"/>
-              </a:rPr>
-              <a:t>FF:FF:0A:0A:00:0A</a:t>
-            </a:r>
-          </a:p>
-        </p:txBody>
-      </p:sp>
-      <p:sp>
-        <p:nvSpPr>
-          <p:cNvPr id="83" name="CaixaDeTexto 82">
-            <a:extLst>
-              <a:ext uri="{FF2B5EF4-FFF2-40B4-BE49-F238E27FC236}">
-                <a16:creationId xmlns:a16="http://schemas.microsoft.com/office/drawing/2014/main" id="{9E33DE23-2BC3-414C-B08A-54D7CD2CDA81}"/>
-              </a:ext>
-            </a:extLst>
-          </p:cNvPr>
-          <p:cNvSpPr txBox="1"/>
-          <p:nvPr/>
-        </p:nvSpPr>
-        <p:spPr>
-          <a:xfrm>
-            <a:off x="2433245" y="6304763"/>
-            <a:ext cx="958917" cy="288541"/>
-          </a:xfrm>
-          <a:prstGeom prst="rect">
-            <a:avLst/>
-          </a:prstGeom>
-          <a:noFill/>
-        </p:spPr>
-        <p:txBody>
-          <a:bodyPr wrap="none" rtlCol="0">
-            <a:spAutoFit/>
-          </a:bodyPr>
-          <a:lstStyle/>
-          <a:p>
-            <a:pPr algn="ctr"/>
-            <a:r>
-              <a:rPr lang="pt-BR" sz="1275" spc="0" baseline="0" dirty="0">
-                <a:solidFill>
-                  <a:srgbClr val="4D4D4D"/>
-                </a:solidFill>
-                <a:latin typeface="Arial"/>
-                <a:cs typeface="Arial"/>
-                <a:sym typeface="Arial"/>
-                <a:rtl val="0"/>
-              </a:rPr>
-              <a:t>10.10.0.10</a:t>
-            </a:r>
-          </a:p>
-        </p:txBody>
-      </p:sp>
       <p:pic>
         <p:nvPicPr>
           <p:cNvPr id="84" name="Imagem 83">
@@ -6366,94 +6103,6 @@
           </a:prstGeom>
         </p:spPr>
       </p:pic>
-      <p:sp>
-        <p:nvSpPr>
-          <p:cNvPr id="88" name="CaixaDeTexto 87">
-            <a:extLst>
-              <a:ext uri="{FF2B5EF4-FFF2-40B4-BE49-F238E27FC236}">
-                <a16:creationId xmlns:a16="http://schemas.microsoft.com/office/drawing/2014/main" id="{23E91CA2-01FD-4548-A584-959EB0E3F0E3}"/>
-              </a:ext>
-            </a:extLst>
-          </p:cNvPr>
-          <p:cNvSpPr txBox="1"/>
-          <p:nvPr/>
-        </p:nvSpPr>
-        <p:spPr>
-          <a:xfrm>
-            <a:off x="7915106" y="6525457"/>
-            <a:ext cx="1600118" cy="288541"/>
-          </a:xfrm>
-          <a:prstGeom prst="rect">
-            <a:avLst/>
-          </a:prstGeom>
-          <a:noFill/>
-        </p:spPr>
-        <p:txBody>
-          <a:bodyPr wrap="none" rtlCol="0">
-            <a:spAutoFit/>
-          </a:bodyPr>
-          <a:lstStyle/>
-          <a:p>
-            <a:pPr algn="ctr"/>
-            <a:r>
-              <a:rPr lang="pt-BR" sz="1275" spc="0" baseline="0" dirty="0">
-                <a:solidFill>
-                  <a:srgbClr val="4D4D4D"/>
-                </a:solidFill>
-                <a:latin typeface="Arial"/>
-                <a:cs typeface="Arial"/>
-                <a:sym typeface="Arial"/>
-                <a:rtl val="0"/>
-              </a:rPr>
-              <a:t>FF:FF:0A:0A:00:0D</a:t>
-            </a:r>
-          </a:p>
-        </p:txBody>
-      </p:sp>
-      <p:sp>
-        <p:nvSpPr>
-          <p:cNvPr id="89" name="CaixaDeTexto 88">
-            <a:extLst>
-              <a:ext uri="{FF2B5EF4-FFF2-40B4-BE49-F238E27FC236}">
-                <a16:creationId xmlns:a16="http://schemas.microsoft.com/office/drawing/2014/main" id="{6D6F7AD6-A742-406D-A1F6-AB2D0CD6BD1A}"/>
-              </a:ext>
-            </a:extLst>
-          </p:cNvPr>
-          <p:cNvSpPr txBox="1"/>
-          <p:nvPr/>
-        </p:nvSpPr>
-        <p:spPr>
-          <a:xfrm>
-            <a:off x="8230375" y="6304763"/>
-            <a:ext cx="958917" cy="288541"/>
-          </a:xfrm>
-          <a:prstGeom prst="rect">
-            <a:avLst/>
-          </a:prstGeom>
-          <a:noFill/>
-        </p:spPr>
-        <p:txBody>
-          <a:bodyPr wrap="none" rtlCol="0">
-            <a:spAutoFit/>
-          </a:bodyPr>
-          <a:lstStyle/>
-          <a:p>
-            <a:pPr algn="ctr"/>
-            <a:r>
-              <a:rPr lang="pt-BR" sz="1275" spc="0" baseline="0" dirty="0">
-                <a:solidFill>
-                  <a:srgbClr val="4D4D4D"/>
-                </a:solidFill>
-                <a:latin typeface="Arial"/>
-                <a:cs typeface="Arial"/>
-                <a:sym typeface="Arial"/>
-                <a:rtl val="0"/>
-              </a:rPr>
-              <a:t>10.10.0.13</a:t>
-            </a:r>
-          </a:p>
-        </p:txBody>
-      </p:sp>
       <p:pic>
         <p:nvPicPr>
           <p:cNvPr id="90" name="Imagem 89">
@@ -6484,94 +6133,6 @@
           </a:prstGeom>
         </p:spPr>
       </p:pic>
-      <p:sp>
-        <p:nvSpPr>
-          <p:cNvPr id="75" name="CaixaDeTexto 74">
-            <a:extLst>
-              <a:ext uri="{FF2B5EF4-FFF2-40B4-BE49-F238E27FC236}">
-                <a16:creationId xmlns:a16="http://schemas.microsoft.com/office/drawing/2014/main" id="{5BFE0F38-0B16-441D-96C3-E4B1A59F88AC}"/>
-              </a:ext>
-            </a:extLst>
-          </p:cNvPr>
-          <p:cNvSpPr txBox="1"/>
-          <p:nvPr/>
-        </p:nvSpPr>
-        <p:spPr>
-          <a:xfrm>
-            <a:off x="8292637" y="1824677"/>
-            <a:ext cx="1324402" cy="288541"/>
-          </a:xfrm>
-          <a:prstGeom prst="rect">
-            <a:avLst/>
-          </a:prstGeom>
-          <a:noFill/>
-        </p:spPr>
-        <p:txBody>
-          <a:bodyPr wrap="none" rtlCol="0">
-            <a:spAutoFit/>
-          </a:bodyPr>
-          <a:lstStyle/>
-          <a:p>
-            <a:pPr algn="ctr"/>
-            <a:r>
-              <a:rPr lang="pt-BR" sz="1275" spc="0" baseline="0" dirty="0">
-                <a:solidFill>
-                  <a:srgbClr val="8F12B2"/>
-                </a:solidFill>
-                <a:latin typeface="Arial"/>
-                <a:cs typeface="Arial"/>
-                <a:sym typeface="Arial"/>
-                <a:rtl val="0"/>
-              </a:rPr>
-              <a:t>205,251.193.51</a:t>
-            </a:r>
-          </a:p>
-        </p:txBody>
-      </p:sp>
-      <p:sp>
-        <p:nvSpPr>
-          <p:cNvPr id="76" name="CaixaDeTexto 75">
-            <a:extLst>
-              <a:ext uri="{FF2B5EF4-FFF2-40B4-BE49-F238E27FC236}">
-                <a16:creationId xmlns:a16="http://schemas.microsoft.com/office/drawing/2014/main" id="{09539BAD-8648-4992-BCCD-DDFDC4B86742}"/>
-              </a:ext>
-            </a:extLst>
-          </p:cNvPr>
-          <p:cNvSpPr txBox="1"/>
-          <p:nvPr/>
-        </p:nvSpPr>
-        <p:spPr>
-          <a:xfrm>
-            <a:off x="8132341" y="2045371"/>
-            <a:ext cx="1645002" cy="288541"/>
-          </a:xfrm>
-          <a:prstGeom prst="rect">
-            <a:avLst/>
-          </a:prstGeom>
-          <a:noFill/>
-        </p:spPr>
-        <p:txBody>
-          <a:bodyPr wrap="none" rtlCol="0">
-            <a:spAutoFit/>
-          </a:bodyPr>
-          <a:lstStyle/>
-          <a:p>
-            <a:pPr algn="ctr"/>
-            <a:r>
-              <a:rPr lang="pt-BR" sz="1275" spc="0" baseline="0" dirty="0">
-                <a:solidFill>
-                  <a:srgbClr val="8F12B2"/>
-                </a:solidFill>
-                <a:latin typeface="Arial"/>
-                <a:cs typeface="Arial"/>
-                <a:sym typeface="Arial"/>
-                <a:rtl val="0"/>
-              </a:rPr>
-              <a:t>FF:FF:CD:FB:C1:33</a:t>
-            </a:r>
-          </a:p>
-        </p:txBody>
-      </p:sp>
       <p:pic>
         <p:nvPicPr>
           <p:cNvPr id="78" name="Imagem 77">
@@ -6616,7 +6177,7 @@
         </p:nvSpPr>
         <p:spPr>
           <a:xfrm>
-            <a:off x="9418115" y="1536136"/>
+            <a:off x="9321082" y="1334240"/>
             <a:ext cx="1293944" cy="288541"/>
           </a:xfrm>
           <a:prstGeom prst="rect">
@@ -6645,103 +6206,6 @@
           </a:p>
         </p:txBody>
       </p:sp>
-      <p:sp>
-        <p:nvSpPr>
-          <p:cNvPr id="143" name="CaixaDeTexto 142">
-            <a:extLst>
-              <a:ext uri="{FF2B5EF4-FFF2-40B4-BE49-F238E27FC236}">
-                <a16:creationId xmlns:a16="http://schemas.microsoft.com/office/drawing/2014/main" id="{7DD8A38D-F3D4-4D09-A1A9-BC37DF685D77}"/>
-              </a:ext>
-            </a:extLst>
-          </p:cNvPr>
-          <p:cNvSpPr txBox="1"/>
-          <p:nvPr/>
-        </p:nvSpPr>
-        <p:spPr>
-          <a:xfrm>
-            <a:off x="8292633" y="3066165"/>
-            <a:ext cx="1324402" cy="288541"/>
-          </a:xfrm>
-          <a:prstGeom prst="rect">
-            <a:avLst/>
-          </a:prstGeom>
-          <a:noFill/>
-        </p:spPr>
-        <p:txBody>
-          <a:bodyPr wrap="none" rtlCol="0">
-            <a:spAutoFit/>
-          </a:bodyPr>
-          <a:lstStyle/>
-          <a:p>
-            <a:pPr algn="ctr"/>
-            <a:r>
-              <a:rPr lang="pt-BR" sz="1275" dirty="0">
-                <a:solidFill>
-                  <a:srgbClr val="8F12B2"/>
-                </a:solidFill>
-                <a:latin typeface="Arial"/>
-                <a:cs typeface="Arial"/>
-                <a:sym typeface="Arial"/>
-                <a:rtl val="0"/>
-              </a:rPr>
-              <a:t>205.251.193.50</a:t>
-            </a:r>
-            <a:endParaRPr lang="pt-BR" sz="1275" spc="0" baseline="0" dirty="0">
-              <a:solidFill>
-                <a:srgbClr val="8F12B2"/>
-              </a:solidFill>
-              <a:latin typeface="Arial"/>
-              <a:cs typeface="Arial"/>
-              <a:sym typeface="Arial"/>
-              <a:rtl val="0"/>
-            </a:endParaRPr>
-          </a:p>
-        </p:txBody>
-      </p:sp>
-      <p:sp>
-        <p:nvSpPr>
-          <p:cNvPr id="144" name="CaixaDeTexto 143">
-            <a:extLst>
-              <a:ext uri="{FF2B5EF4-FFF2-40B4-BE49-F238E27FC236}">
-                <a16:creationId xmlns:a16="http://schemas.microsoft.com/office/drawing/2014/main" id="{BC5DE6A7-3E3A-459F-94B5-DD56BE3735A3}"/>
-              </a:ext>
-            </a:extLst>
-          </p:cNvPr>
-          <p:cNvSpPr txBox="1"/>
-          <p:nvPr/>
-        </p:nvSpPr>
-        <p:spPr>
-          <a:xfrm>
-            <a:off x="8132340" y="3286859"/>
-            <a:ext cx="1645002" cy="288541"/>
-          </a:xfrm>
-          <a:prstGeom prst="rect">
-            <a:avLst/>
-          </a:prstGeom>
-          <a:noFill/>
-        </p:spPr>
-        <p:txBody>
-          <a:bodyPr wrap="none" rtlCol="0">
-            <a:spAutoFit/>
-          </a:bodyPr>
-          <a:lstStyle/>
-          <a:p>
-            <a:pPr algn="ctr"/>
-            <a:r>
-              <a:rPr lang="pt-BR" sz="1275" spc="0" baseline="0" dirty="0">
-                <a:solidFill>
-                  <a:srgbClr val="8F12B2"/>
-                </a:solidFill>
-                <a:latin typeface="Arial"/>
-                <a:cs typeface="Arial"/>
-                <a:sym typeface="Arial"/>
-                <a:rtl val="0"/>
-              </a:rPr>
-              <a:t>FF:FF:CD:FB:C1:38</a:t>
-            </a:r>
-          </a:p>
-        </p:txBody>
-      </p:sp>
       <p:pic>
         <p:nvPicPr>
           <p:cNvPr id="145" name="Imagem 144">
@@ -6786,7 +6250,7 @@
         </p:nvSpPr>
         <p:spPr>
           <a:xfrm>
-            <a:off x="9418115" y="2713444"/>
+            <a:off x="9321435" y="2477168"/>
             <a:ext cx="1705916" cy="484748"/>
           </a:xfrm>
           <a:prstGeom prst="rect">
@@ -6862,94 +6326,6 @@
           </a:p>
         </p:txBody>
       </p:sp>
-      <p:sp>
-        <p:nvSpPr>
-          <p:cNvPr id="148" name="CaixaDeTexto 147">
-            <a:extLst>
-              <a:ext uri="{FF2B5EF4-FFF2-40B4-BE49-F238E27FC236}">
-                <a16:creationId xmlns:a16="http://schemas.microsoft.com/office/drawing/2014/main" id="{B4FE58D5-6C70-4908-97EE-852E11EF2C1A}"/>
-              </a:ext>
-            </a:extLst>
-          </p:cNvPr>
-          <p:cNvSpPr txBox="1"/>
-          <p:nvPr/>
-        </p:nvSpPr>
-        <p:spPr>
-          <a:xfrm>
-            <a:off x="8215024" y="4334621"/>
-            <a:ext cx="1415772" cy="288541"/>
-          </a:xfrm>
-          <a:prstGeom prst="rect">
-            <a:avLst/>
-          </a:prstGeom>
-          <a:noFill/>
-        </p:spPr>
-        <p:txBody>
-          <a:bodyPr wrap="none" rtlCol="0">
-            <a:spAutoFit/>
-          </a:bodyPr>
-          <a:lstStyle/>
-          <a:p>
-            <a:pPr algn="ctr"/>
-            <a:r>
-              <a:rPr lang="pt-BR" sz="1275" dirty="0">
-                <a:solidFill>
-                  <a:srgbClr val="8F12B2"/>
-                </a:solidFill>
-                <a:latin typeface="Arial"/>
-                <a:cs typeface="Arial"/>
-                <a:sym typeface="Arial"/>
-                <a:rtl val="0"/>
-              </a:rPr>
-              <a:t>205.251.193.203</a:t>
-            </a:r>
-          </a:p>
-        </p:txBody>
-      </p:sp>
-      <p:sp>
-        <p:nvSpPr>
-          <p:cNvPr id="149" name="CaixaDeTexto 148">
-            <a:extLst>
-              <a:ext uri="{FF2B5EF4-FFF2-40B4-BE49-F238E27FC236}">
-                <a16:creationId xmlns:a16="http://schemas.microsoft.com/office/drawing/2014/main" id="{44C17DB9-5DA2-4A59-B56A-77ABDE3FBF31}"/>
-              </a:ext>
-            </a:extLst>
-          </p:cNvPr>
-          <p:cNvSpPr txBox="1"/>
-          <p:nvPr/>
-        </p:nvSpPr>
-        <p:spPr>
-          <a:xfrm>
-            <a:off x="8031507" y="4543658"/>
-            <a:ext cx="1689886" cy="288541"/>
-          </a:xfrm>
-          <a:prstGeom prst="rect">
-            <a:avLst/>
-          </a:prstGeom>
-          <a:noFill/>
-        </p:spPr>
-        <p:txBody>
-          <a:bodyPr wrap="none" rtlCol="0">
-            <a:spAutoFit/>
-          </a:bodyPr>
-          <a:lstStyle/>
-          <a:p>
-            <a:pPr algn="ctr"/>
-            <a:r>
-              <a:rPr lang="pt-BR" sz="1275" spc="0" baseline="0" dirty="0">
-                <a:solidFill>
-                  <a:srgbClr val="8F12B2"/>
-                </a:solidFill>
-                <a:latin typeface="Arial"/>
-                <a:cs typeface="Arial"/>
-                <a:sym typeface="Arial"/>
-                <a:rtl val="0"/>
-              </a:rPr>
-              <a:t>FF:FF:CD:FB:C1:CB</a:t>
-            </a:r>
-          </a:p>
-        </p:txBody>
-      </p:sp>
       <p:pic>
         <p:nvPicPr>
           <p:cNvPr id="150" name="Imagem 149">
@@ -6994,7 +6370,7 @@
         </p:nvSpPr>
         <p:spPr>
           <a:xfrm>
-            <a:off x="9418114" y="4019111"/>
+            <a:off x="9353034" y="3822983"/>
             <a:ext cx="1376265" cy="288541"/>
           </a:xfrm>
           <a:prstGeom prst="rect">
@@ -7083,94 +6459,6 @@
           </a:prstGeom>
         </p:spPr>
       </p:pic>
-      <p:sp>
-        <p:nvSpPr>
-          <p:cNvPr id="171" name="CaixaDeTexto 170">
-            <a:extLst>
-              <a:ext uri="{FF2B5EF4-FFF2-40B4-BE49-F238E27FC236}">
-                <a16:creationId xmlns:a16="http://schemas.microsoft.com/office/drawing/2014/main" id="{233930AA-DDBD-4AAE-8217-77B215A5B047}"/>
-              </a:ext>
-            </a:extLst>
-          </p:cNvPr>
-          <p:cNvSpPr txBox="1"/>
-          <p:nvPr/>
-        </p:nvSpPr>
-        <p:spPr>
-          <a:xfrm>
-            <a:off x="1405359" y="3146522"/>
-            <a:ext cx="1324402" cy="288541"/>
-          </a:xfrm>
-          <a:prstGeom prst="rect">
-            <a:avLst/>
-          </a:prstGeom>
-          <a:noFill/>
-        </p:spPr>
-        <p:txBody>
-          <a:bodyPr wrap="none" rtlCol="0">
-            <a:spAutoFit/>
-          </a:bodyPr>
-          <a:lstStyle/>
-          <a:p>
-            <a:pPr algn="ctr"/>
-            <a:r>
-              <a:rPr lang="pt-BR" sz="1275" spc="0" baseline="0" dirty="0">
-                <a:solidFill>
-                  <a:srgbClr val="8F12B2"/>
-                </a:solidFill>
-                <a:latin typeface="Arial"/>
-                <a:cs typeface="Arial"/>
-                <a:sym typeface="Arial"/>
-                <a:rtl val="0"/>
-              </a:rPr>
-              <a:t>205.251.10.147</a:t>
-            </a:r>
-          </a:p>
-        </p:txBody>
-      </p:sp>
-      <p:sp>
-        <p:nvSpPr>
-          <p:cNvPr id="172" name="CaixaDeTexto 171">
-            <a:extLst>
-              <a:ext uri="{FF2B5EF4-FFF2-40B4-BE49-F238E27FC236}">
-                <a16:creationId xmlns:a16="http://schemas.microsoft.com/office/drawing/2014/main" id="{F44AC269-31F6-4F66-A03F-C66F367DEF37}"/>
-              </a:ext>
-            </a:extLst>
-          </p:cNvPr>
-          <p:cNvSpPr txBox="1"/>
-          <p:nvPr/>
-        </p:nvSpPr>
-        <p:spPr>
-          <a:xfrm>
-            <a:off x="1249867" y="3367216"/>
-            <a:ext cx="1635384" cy="288541"/>
-          </a:xfrm>
-          <a:prstGeom prst="rect">
-            <a:avLst/>
-          </a:prstGeom>
-          <a:noFill/>
-        </p:spPr>
-        <p:txBody>
-          <a:bodyPr wrap="none" rtlCol="0">
-            <a:spAutoFit/>
-          </a:bodyPr>
-          <a:lstStyle/>
-          <a:p>
-            <a:pPr algn="ctr"/>
-            <a:r>
-              <a:rPr lang="en-US" sz="1275" spc="0" baseline="0" dirty="0">
-                <a:solidFill>
-                  <a:srgbClr val="8F12B2"/>
-                </a:solidFill>
-                <a:latin typeface="Arial"/>
-                <a:cs typeface="Arial"/>
-                <a:sym typeface="Arial"/>
-                <a:rtl val="0"/>
-              </a:rPr>
-              <a:t>FF:FF:CD:FB:0A:93</a:t>
-            </a:r>
-          </a:p>
-        </p:txBody>
-      </p:sp>
       <p:pic>
         <p:nvPicPr>
           <p:cNvPr id="173" name="Imagem 172">
@@ -7215,7 +6503,7 @@
         </p:nvSpPr>
         <p:spPr>
           <a:xfrm>
-            <a:off x="166778" y="2857981"/>
+            <a:off x="469460" y="2725172"/>
             <a:ext cx="1376265" cy="288541"/>
           </a:xfrm>
           <a:prstGeom prst="rect">
@@ -7244,103 +6532,6 @@
           </a:p>
         </p:txBody>
       </p:sp>
-      <p:sp>
-        <p:nvSpPr>
-          <p:cNvPr id="180" name="CaixaDeTexto 179">
-            <a:extLst>
-              <a:ext uri="{FF2B5EF4-FFF2-40B4-BE49-F238E27FC236}">
-                <a16:creationId xmlns:a16="http://schemas.microsoft.com/office/drawing/2014/main" id="{1C803C71-8E33-4C90-80F0-81B66A97BC5A}"/>
-              </a:ext>
-            </a:extLst>
-          </p:cNvPr>
-          <p:cNvSpPr txBox="1"/>
-          <p:nvPr/>
-        </p:nvSpPr>
-        <p:spPr>
-          <a:xfrm>
-            <a:off x="1451040" y="4447539"/>
-            <a:ext cx="1233031" cy="288541"/>
-          </a:xfrm>
-          <a:prstGeom prst="rect">
-            <a:avLst/>
-          </a:prstGeom>
-          <a:noFill/>
-        </p:spPr>
-        <p:txBody>
-          <a:bodyPr wrap="none" rtlCol="0">
-            <a:spAutoFit/>
-          </a:bodyPr>
-          <a:lstStyle/>
-          <a:p>
-            <a:pPr algn="ctr"/>
-            <a:r>
-              <a:rPr lang="pt-BR" sz="1275" dirty="0">
-                <a:solidFill>
-                  <a:srgbClr val="8F12B2"/>
-                </a:solidFill>
-                <a:latin typeface="Arial"/>
-                <a:cs typeface="Arial"/>
-                <a:sym typeface="Arial"/>
-                <a:rtl val="0"/>
-              </a:rPr>
-              <a:t>205.251.10.82</a:t>
-            </a:r>
-            <a:endParaRPr lang="pt-BR" sz="1275" spc="0" baseline="0" dirty="0">
-              <a:solidFill>
-                <a:srgbClr val="8F12B2"/>
-              </a:solidFill>
-              <a:latin typeface="Arial"/>
-              <a:cs typeface="Arial"/>
-              <a:sym typeface="Arial"/>
-              <a:rtl val="0"/>
-            </a:endParaRPr>
-          </a:p>
-        </p:txBody>
-      </p:sp>
-      <p:sp>
-        <p:nvSpPr>
-          <p:cNvPr id="181" name="CaixaDeTexto 180">
-            <a:extLst>
-              <a:ext uri="{FF2B5EF4-FFF2-40B4-BE49-F238E27FC236}">
-                <a16:creationId xmlns:a16="http://schemas.microsoft.com/office/drawing/2014/main" id="{B61BEF6B-5185-4CC0-B4B2-0A0A47ED4FEB}"/>
-              </a:ext>
-            </a:extLst>
-          </p:cNvPr>
-          <p:cNvSpPr txBox="1"/>
-          <p:nvPr/>
-        </p:nvSpPr>
-        <p:spPr>
-          <a:xfrm>
-            <a:off x="1249867" y="4668233"/>
-            <a:ext cx="1635384" cy="288541"/>
-          </a:xfrm>
-          <a:prstGeom prst="rect">
-            <a:avLst/>
-          </a:prstGeom>
-          <a:noFill/>
-        </p:spPr>
-        <p:txBody>
-          <a:bodyPr wrap="none" rtlCol="0">
-            <a:spAutoFit/>
-          </a:bodyPr>
-          <a:lstStyle/>
-          <a:p>
-            <a:pPr algn="ctr"/>
-            <a:r>
-              <a:rPr lang="en-US" sz="1275" spc="0" baseline="0" dirty="0">
-                <a:solidFill>
-                  <a:srgbClr val="8F12B2"/>
-                </a:solidFill>
-                <a:latin typeface="Arial"/>
-                <a:cs typeface="Arial"/>
-                <a:sym typeface="Arial"/>
-                <a:rtl val="0"/>
-              </a:rPr>
-              <a:t>FF:FF:CD:FB:0A:52</a:t>
-            </a:r>
-          </a:p>
-        </p:txBody>
-      </p:sp>
       <p:pic>
         <p:nvPicPr>
           <p:cNvPr id="182" name="Imagem 181">
@@ -7385,7 +6576,7 @@
         </p:nvSpPr>
         <p:spPr>
           <a:xfrm>
-            <a:off x="166778" y="4158998"/>
+            <a:off x="338571" y="4012771"/>
             <a:ext cx="1376265" cy="288541"/>
           </a:xfrm>
           <a:prstGeom prst="rect">
@@ -8494,446 +7685,6 @@
       </p:cxnSp>
       <p:sp>
         <p:nvSpPr>
-          <p:cNvPr id="290" name="CaixaDeTexto 289">
-            <a:extLst>
-              <a:ext uri="{FF2B5EF4-FFF2-40B4-BE49-F238E27FC236}">
-                <a16:creationId xmlns:a16="http://schemas.microsoft.com/office/drawing/2014/main" id="{E02149A2-629D-4448-95A6-27072C0A94AF}"/>
-              </a:ext>
-            </a:extLst>
-          </p:cNvPr>
-          <p:cNvSpPr txBox="1"/>
-          <p:nvPr/>
-        </p:nvSpPr>
-        <p:spPr>
-          <a:xfrm>
-            <a:off x="5051923" y="4530556"/>
-            <a:ext cx="1603324" cy="288541"/>
-          </a:xfrm>
-          <a:prstGeom prst="rect">
-            <a:avLst/>
-          </a:prstGeom>
-          <a:noFill/>
-        </p:spPr>
-        <p:txBody>
-          <a:bodyPr wrap="none" rtlCol="0">
-            <a:spAutoFit/>
-          </a:bodyPr>
-          <a:lstStyle/>
-          <a:p>
-            <a:pPr algn="ctr"/>
-            <a:r>
-              <a:rPr lang="pt-BR" sz="1275" spc="0" baseline="0" dirty="0">
-                <a:solidFill>
-                  <a:srgbClr val="00B0F0"/>
-                </a:solidFill>
-                <a:latin typeface="Arial"/>
-                <a:cs typeface="Arial"/>
-                <a:sym typeface="Arial"/>
-                <a:rtl val="0"/>
-              </a:rPr>
-              <a:t>FF:FF:0A:0A:00:01</a:t>
-            </a:r>
-          </a:p>
-        </p:txBody>
-      </p:sp>
-      <p:sp>
-        <p:nvSpPr>
-          <p:cNvPr id="291" name="CaixaDeTexto 290">
-            <a:extLst>
-              <a:ext uri="{FF2B5EF4-FFF2-40B4-BE49-F238E27FC236}">
-                <a16:creationId xmlns:a16="http://schemas.microsoft.com/office/drawing/2014/main" id="{BE5B7E30-48A8-48B2-B9D9-B3950FA97662}"/>
-              </a:ext>
-            </a:extLst>
-          </p:cNvPr>
-          <p:cNvSpPr txBox="1"/>
-          <p:nvPr/>
-        </p:nvSpPr>
-        <p:spPr>
-          <a:xfrm>
-            <a:off x="5410133" y="4309862"/>
-            <a:ext cx="867545" cy="288541"/>
-          </a:xfrm>
-          <a:prstGeom prst="rect">
-            <a:avLst/>
-          </a:prstGeom>
-          <a:noFill/>
-        </p:spPr>
-        <p:txBody>
-          <a:bodyPr wrap="none" rtlCol="0">
-            <a:spAutoFit/>
-          </a:bodyPr>
-          <a:lstStyle/>
-          <a:p>
-            <a:pPr algn="ctr"/>
-            <a:r>
-              <a:rPr lang="pt-BR" sz="1275" spc="0" baseline="0" dirty="0">
-                <a:solidFill>
-                  <a:srgbClr val="00B0F0"/>
-                </a:solidFill>
-                <a:latin typeface="Arial"/>
-                <a:cs typeface="Arial"/>
-                <a:sym typeface="Arial"/>
-                <a:rtl val="0"/>
-              </a:rPr>
-              <a:t>10.10.0.1</a:t>
-            </a:r>
-          </a:p>
-        </p:txBody>
-      </p:sp>
-      <p:sp>
-        <p:nvSpPr>
-          <p:cNvPr id="292" name="CaixaDeTexto 291">
-            <a:extLst>
-              <a:ext uri="{FF2B5EF4-FFF2-40B4-BE49-F238E27FC236}">
-                <a16:creationId xmlns:a16="http://schemas.microsoft.com/office/drawing/2014/main" id="{1A5125EE-EF32-49E1-8564-730F630A5DE3}"/>
-              </a:ext>
-            </a:extLst>
-          </p:cNvPr>
-          <p:cNvSpPr txBox="1"/>
-          <p:nvPr/>
-        </p:nvSpPr>
-        <p:spPr>
-          <a:xfrm>
-            <a:off x="6307205" y="3108120"/>
-            <a:ext cx="1645002" cy="288541"/>
-          </a:xfrm>
-          <a:prstGeom prst="rect">
-            <a:avLst/>
-          </a:prstGeom>
-          <a:noFill/>
-        </p:spPr>
-        <p:txBody>
-          <a:bodyPr wrap="none" rtlCol="0">
-            <a:spAutoFit/>
-          </a:bodyPr>
-          <a:lstStyle/>
-          <a:p>
-            <a:pPr algn="ctr"/>
-            <a:r>
-              <a:rPr lang="pt-BR" sz="1275" spc="0" baseline="0" dirty="0">
-                <a:solidFill>
-                  <a:srgbClr val="00B0F0"/>
-                </a:solidFill>
-                <a:latin typeface="Arial"/>
-                <a:cs typeface="Arial"/>
-                <a:sym typeface="Arial"/>
-                <a:rtl val="0"/>
-              </a:rPr>
-              <a:t>FF:FF:CD:FB:C1:01</a:t>
-            </a:r>
-          </a:p>
-        </p:txBody>
-      </p:sp>
-      <p:sp>
-        <p:nvSpPr>
-          <p:cNvPr id="293" name="CaixaDeTexto 292">
-            <a:extLst>
-              <a:ext uri="{FF2B5EF4-FFF2-40B4-BE49-F238E27FC236}">
-                <a16:creationId xmlns:a16="http://schemas.microsoft.com/office/drawing/2014/main" id="{D27143F2-C3C7-410E-8B5A-511D4931BA9E}"/>
-              </a:ext>
-            </a:extLst>
-          </p:cNvPr>
-          <p:cNvSpPr txBox="1"/>
-          <p:nvPr/>
-        </p:nvSpPr>
-        <p:spPr>
-          <a:xfrm>
-            <a:off x="6503507" y="2887426"/>
-            <a:ext cx="1233031" cy="288541"/>
-          </a:xfrm>
-          <a:prstGeom prst="rect">
-            <a:avLst/>
-          </a:prstGeom>
-          <a:noFill/>
-        </p:spPr>
-        <p:txBody>
-          <a:bodyPr wrap="none" rtlCol="0">
-            <a:spAutoFit/>
-          </a:bodyPr>
-          <a:lstStyle/>
-          <a:p>
-            <a:pPr algn="ctr"/>
-            <a:r>
-              <a:rPr lang="pt-BR" sz="1275" spc="0" baseline="0" dirty="0">
-                <a:solidFill>
-                  <a:srgbClr val="00B0F0"/>
-                </a:solidFill>
-                <a:latin typeface="Arial"/>
-                <a:cs typeface="Arial"/>
-                <a:sym typeface="Arial"/>
-                <a:rtl val="0"/>
-              </a:rPr>
-              <a:t>205.251.193.1</a:t>
-            </a:r>
-          </a:p>
-        </p:txBody>
-      </p:sp>
-      <p:sp>
-        <p:nvSpPr>
-          <p:cNvPr id="294" name="CaixaDeTexto 293">
-            <a:extLst>
-              <a:ext uri="{FF2B5EF4-FFF2-40B4-BE49-F238E27FC236}">
-                <a16:creationId xmlns:a16="http://schemas.microsoft.com/office/drawing/2014/main" id="{1B0346EF-A8FB-4FDA-AFA8-DC364789AA5B}"/>
-              </a:ext>
-            </a:extLst>
-          </p:cNvPr>
-          <p:cNvSpPr txBox="1"/>
-          <p:nvPr/>
-        </p:nvSpPr>
-        <p:spPr>
-          <a:xfrm>
-            <a:off x="4613193" y="3448667"/>
-            <a:ext cx="1617751" cy="288541"/>
-          </a:xfrm>
-          <a:prstGeom prst="rect">
-            <a:avLst/>
-          </a:prstGeom>
-          <a:noFill/>
-        </p:spPr>
-        <p:txBody>
-          <a:bodyPr wrap="none" rtlCol="0">
-            <a:spAutoFit/>
-          </a:bodyPr>
-          <a:lstStyle/>
-          <a:p>
-            <a:pPr algn="ctr"/>
-            <a:r>
-              <a:rPr lang="en-US" sz="1275" spc="0" baseline="0" dirty="0">
-                <a:solidFill>
-                  <a:schemeClr val="accent1"/>
-                </a:solidFill>
-                <a:latin typeface="Arial"/>
-                <a:cs typeface="Arial"/>
-                <a:sym typeface="Arial"/>
-                <a:rtl val="0"/>
-              </a:rPr>
-              <a:t>FF:FF:CD:FB:01:01</a:t>
-            </a:r>
-          </a:p>
-        </p:txBody>
-      </p:sp>
-      <p:sp>
-        <p:nvSpPr>
-          <p:cNvPr id="295" name="CaixaDeTexto 294">
-            <a:extLst>
-              <a:ext uri="{FF2B5EF4-FFF2-40B4-BE49-F238E27FC236}">
-                <a16:creationId xmlns:a16="http://schemas.microsoft.com/office/drawing/2014/main" id="{A8E5DA4C-31E8-4ACE-81CC-B9BDB0D29512}"/>
-              </a:ext>
-            </a:extLst>
-          </p:cNvPr>
-          <p:cNvSpPr txBox="1"/>
-          <p:nvPr/>
-        </p:nvSpPr>
-        <p:spPr>
-          <a:xfrm>
-            <a:off x="4887244" y="3227973"/>
-            <a:ext cx="1050288" cy="288541"/>
-          </a:xfrm>
-          <a:prstGeom prst="rect">
-            <a:avLst/>
-          </a:prstGeom>
-          <a:noFill/>
-        </p:spPr>
-        <p:txBody>
-          <a:bodyPr wrap="none" rtlCol="0">
-            <a:spAutoFit/>
-          </a:bodyPr>
-          <a:lstStyle/>
-          <a:p>
-            <a:pPr algn="ctr"/>
-            <a:r>
-              <a:rPr lang="pt-BR" sz="1275" spc="0" baseline="0" dirty="0">
-                <a:solidFill>
-                  <a:schemeClr val="accent1"/>
-                </a:solidFill>
-                <a:latin typeface="Arial"/>
-                <a:cs typeface="Arial"/>
-                <a:sym typeface="Arial"/>
-                <a:rtl val="0"/>
-              </a:rPr>
-              <a:t>205.251.1.1</a:t>
-            </a:r>
-          </a:p>
-        </p:txBody>
-      </p:sp>
-      <p:sp>
-        <p:nvSpPr>
-          <p:cNvPr id="296" name="CaixaDeTexto 295">
-            <a:extLst>
-              <a:ext uri="{FF2B5EF4-FFF2-40B4-BE49-F238E27FC236}">
-                <a16:creationId xmlns:a16="http://schemas.microsoft.com/office/drawing/2014/main" id="{2ABA5E86-658E-4FDD-A02D-0E8DE8928CF0}"/>
-              </a:ext>
-            </a:extLst>
-          </p:cNvPr>
-          <p:cNvSpPr txBox="1"/>
-          <p:nvPr/>
-        </p:nvSpPr>
-        <p:spPr>
-          <a:xfrm>
-            <a:off x="3000568" y="3078675"/>
-            <a:ext cx="1635384" cy="288541"/>
-          </a:xfrm>
-          <a:prstGeom prst="rect">
-            <a:avLst/>
-          </a:prstGeom>
-          <a:noFill/>
-        </p:spPr>
-        <p:txBody>
-          <a:bodyPr wrap="none" rtlCol="0">
-            <a:spAutoFit/>
-          </a:bodyPr>
-          <a:lstStyle/>
-          <a:p>
-            <a:pPr algn="ctr"/>
-            <a:r>
-              <a:rPr lang="pt-BR" sz="1275" spc="0" baseline="0" dirty="0">
-                <a:solidFill>
-                  <a:srgbClr val="00B0F0"/>
-                </a:solidFill>
-                <a:latin typeface="Arial"/>
-                <a:cs typeface="Arial"/>
-                <a:sym typeface="Arial"/>
-                <a:rtl val="0"/>
-              </a:rPr>
-              <a:t>FF:FF:CD:FB:0A:01</a:t>
-            </a:r>
-          </a:p>
-        </p:txBody>
-      </p:sp>
-      <p:sp>
-        <p:nvSpPr>
-          <p:cNvPr id="297" name="CaixaDeTexto 296">
-            <a:extLst>
-              <a:ext uri="{FF2B5EF4-FFF2-40B4-BE49-F238E27FC236}">
-                <a16:creationId xmlns:a16="http://schemas.microsoft.com/office/drawing/2014/main" id="{11C3DB5B-0D63-4B15-8F86-7DC78A32A73D}"/>
-              </a:ext>
-            </a:extLst>
-          </p:cNvPr>
-          <p:cNvSpPr txBox="1"/>
-          <p:nvPr/>
-        </p:nvSpPr>
-        <p:spPr>
-          <a:xfrm>
-            <a:off x="3237747" y="2857981"/>
-            <a:ext cx="1141659" cy="288541"/>
-          </a:xfrm>
-          <a:prstGeom prst="rect">
-            <a:avLst/>
-          </a:prstGeom>
-          <a:noFill/>
-        </p:spPr>
-        <p:txBody>
-          <a:bodyPr wrap="none" rtlCol="0">
-            <a:spAutoFit/>
-          </a:bodyPr>
-          <a:lstStyle/>
-          <a:p>
-            <a:pPr algn="ctr"/>
-            <a:r>
-              <a:rPr lang="pt-BR" sz="1275" spc="0" baseline="0" dirty="0">
-                <a:solidFill>
-                  <a:srgbClr val="00B0F0"/>
-                </a:solidFill>
-                <a:latin typeface="Arial"/>
-                <a:cs typeface="Arial"/>
-                <a:sym typeface="Arial"/>
-                <a:rtl val="0"/>
-              </a:rPr>
-              <a:t>205.251.10.1</a:t>
-            </a:r>
-          </a:p>
-        </p:txBody>
-      </p:sp>
-      <p:sp>
-        <p:nvSpPr>
-          <p:cNvPr id="298" name="CaixaDeTexto 297">
-            <a:extLst>
-              <a:ext uri="{FF2B5EF4-FFF2-40B4-BE49-F238E27FC236}">
-                <a16:creationId xmlns:a16="http://schemas.microsoft.com/office/drawing/2014/main" id="{0E59932A-EE4B-4204-9B58-33921791E136}"/>
-              </a:ext>
-            </a:extLst>
-          </p:cNvPr>
-          <p:cNvSpPr txBox="1"/>
-          <p:nvPr/>
-        </p:nvSpPr>
-        <p:spPr>
-          <a:xfrm>
-            <a:off x="3527917" y="739237"/>
-            <a:ext cx="1592103" cy="288541"/>
-          </a:xfrm>
-          <a:prstGeom prst="rect">
-            <a:avLst/>
-          </a:prstGeom>
-          <a:noFill/>
-        </p:spPr>
-        <p:txBody>
-          <a:bodyPr wrap="none" rtlCol="0">
-            <a:spAutoFit/>
-          </a:bodyPr>
-          <a:lstStyle/>
-          <a:p>
-            <a:pPr algn="ctr"/>
-            <a:r>
-              <a:rPr lang="pt-BR" sz="1275" spc="0" baseline="0" dirty="0">
-                <a:solidFill>
-                  <a:schemeClr val="accent1"/>
-                </a:solidFill>
-                <a:latin typeface="Arial"/>
-                <a:cs typeface="Arial"/>
-                <a:sym typeface="Arial"/>
-                <a:rtl val="0"/>
-              </a:rPr>
-              <a:t>FF:FF:CD:01:01:01</a:t>
-            </a:r>
-          </a:p>
-        </p:txBody>
-      </p:sp>
-      <p:sp>
-        <p:nvSpPr>
-          <p:cNvPr id="299" name="CaixaDeTexto 298">
-            <a:extLst>
-              <a:ext uri="{FF2B5EF4-FFF2-40B4-BE49-F238E27FC236}">
-                <a16:creationId xmlns:a16="http://schemas.microsoft.com/office/drawing/2014/main" id="{213B0DCC-5EB2-44CB-8CAD-038DC26D225B}"/>
-              </a:ext>
-            </a:extLst>
-          </p:cNvPr>
-          <p:cNvSpPr txBox="1"/>
-          <p:nvPr/>
-        </p:nvSpPr>
-        <p:spPr>
-          <a:xfrm>
-            <a:off x="3880514" y="518543"/>
-            <a:ext cx="867545" cy="288541"/>
-          </a:xfrm>
-          <a:prstGeom prst="rect">
-            <a:avLst/>
-          </a:prstGeom>
-          <a:noFill/>
-        </p:spPr>
-        <p:txBody>
-          <a:bodyPr wrap="none" rtlCol="0">
-            <a:spAutoFit/>
-          </a:bodyPr>
-          <a:lstStyle/>
-          <a:p>
-            <a:pPr algn="ctr"/>
-            <a:r>
-              <a:rPr lang="pt-BR" sz="1275" spc="0" baseline="0" dirty="0">
-                <a:solidFill>
-                  <a:schemeClr val="accent1"/>
-                </a:solidFill>
-                <a:latin typeface="Arial"/>
-                <a:cs typeface="Arial"/>
-                <a:sym typeface="Arial"/>
-                <a:rtl val="0"/>
-              </a:rPr>
-              <a:t>205.1.1.1</a:t>
-            </a:r>
-          </a:p>
-        </p:txBody>
-      </p:sp>
-      <p:sp>
-        <p:nvSpPr>
           <p:cNvPr id="320" name="CaixaDeTexto 319">
             <a:extLst>
               <a:ext uri="{FF2B5EF4-FFF2-40B4-BE49-F238E27FC236}">
@@ -9202,7 +7953,7 @@
         </p:nvSpPr>
         <p:spPr>
           <a:xfrm>
-            <a:off x="6796987" y="3780694"/>
+            <a:off x="6661591" y="3152000"/>
             <a:ext cx="1056700" cy="288541"/>
           </a:xfrm>
           <a:prstGeom prst="rect">
@@ -9246,7 +7997,7 @@
         </p:nvSpPr>
         <p:spPr>
           <a:xfrm>
-            <a:off x="6796987" y="5165627"/>
+            <a:off x="7200120" y="4772944"/>
             <a:ext cx="1056700" cy="288541"/>
           </a:xfrm>
           <a:prstGeom prst="rect">
@@ -9734,6 +8485,2417 @@
     <p:extLst>
       <p:ext uri="{BB962C8B-B14F-4D97-AF65-F5344CB8AC3E}">
         <p14:creationId xmlns:p14="http://schemas.microsoft.com/office/powerpoint/2010/main" val="3335338585"/>
+      </p:ext>
+    </p:extLst>
+  </p:cSld>
+  <p:clrMapOvr>
+    <a:masterClrMapping/>
+  </p:clrMapOvr>
+</p:sld>
+</file>
+
+<file path=ppt/slides/slide3.xml><?xml version="1.0" encoding="utf-8"?>
+<p:sld xmlns:a="http://schemas.openxmlformats.org/drawingml/2006/main" xmlns:r="http://schemas.openxmlformats.org/officeDocument/2006/relationships" xmlns:p="http://schemas.openxmlformats.org/presentationml/2006/main">
+  <p:cSld>
+    <p:spTree>
+      <p:nvGrpSpPr>
+        <p:cNvPr id="1" name=""/>
+        <p:cNvGrpSpPr/>
+        <p:nvPr/>
+      </p:nvGrpSpPr>
+      <p:grpSpPr>
+        <a:xfrm>
+          <a:off x="0" y="0"/>
+          <a:ext cx="0" cy="0"/>
+          <a:chOff x="0" y="0"/>
+          <a:chExt cx="0" cy="0"/>
+        </a:xfrm>
+      </p:grpSpPr>
+      <p:sp>
+        <p:nvSpPr>
+          <p:cNvPr id="52" name="CaixaDeTexto 51">
+            <a:extLst>
+              <a:ext uri="{FF2B5EF4-FFF2-40B4-BE49-F238E27FC236}">
+                <a16:creationId xmlns:a16="http://schemas.microsoft.com/office/drawing/2014/main" id="{4291983A-7550-43C9-BDE1-ABDC7B31DA75}"/>
+              </a:ext>
+            </a:extLst>
+          </p:cNvPr>
+          <p:cNvSpPr txBox="1"/>
+          <p:nvPr/>
+        </p:nvSpPr>
+        <p:spPr>
+          <a:xfrm>
+            <a:off x="6297999" y="6304763"/>
+            <a:ext cx="958917" cy="288541"/>
+          </a:xfrm>
+          <a:prstGeom prst="rect">
+            <a:avLst/>
+          </a:prstGeom>
+          <a:noFill/>
+        </p:spPr>
+        <p:txBody>
+          <a:bodyPr wrap="none" rtlCol="0">
+            <a:spAutoFit/>
+          </a:bodyPr>
+          <a:lstStyle/>
+          <a:p>
+            <a:pPr algn="ctr"/>
+            <a:r>
+              <a:rPr lang="pt-BR" sz="1275" spc="0" baseline="0" dirty="0">
+                <a:solidFill>
+                  <a:srgbClr val="4D4D4D"/>
+                </a:solidFill>
+                <a:latin typeface="Arial"/>
+                <a:cs typeface="Arial"/>
+                <a:sym typeface="Arial"/>
+                <a:rtl val="0"/>
+              </a:rPr>
+              <a:t>10.10.0.12</a:t>
+            </a:r>
+          </a:p>
+        </p:txBody>
+      </p:sp>
+      <p:pic>
+        <p:nvPicPr>
+          <p:cNvPr id="2" name="Imagem 1">
+            <a:extLst>
+              <a:ext uri="{FF2B5EF4-FFF2-40B4-BE49-F238E27FC236}">
+                <a16:creationId xmlns:a16="http://schemas.microsoft.com/office/drawing/2014/main" id="{958022CB-DEB5-4A89-A24F-768F1F26D4C7}"/>
+              </a:ext>
+            </a:extLst>
+          </p:cNvPr>
+          <p:cNvPicPr>
+            <a:picLocks noChangeAspect="1"/>
+          </p:cNvPicPr>
+          <p:nvPr/>
+        </p:nvPicPr>
+        <p:blipFill>
+          <a:blip r:embed="rId2"/>
+          <a:stretch>
+            <a:fillRect/>
+          </a:stretch>
+        </p:blipFill>
+        <p:spPr>
+          <a:xfrm>
+            <a:off x="6427690" y="5710691"/>
+            <a:ext cx="699529" cy="594072"/>
+          </a:xfrm>
+          <a:prstGeom prst="rect">
+            <a:avLst/>
+          </a:prstGeom>
+        </p:spPr>
+      </p:pic>
+      <p:sp>
+        <p:nvSpPr>
+          <p:cNvPr id="80" name="CaixaDeTexto 79">
+            <a:extLst>
+              <a:ext uri="{FF2B5EF4-FFF2-40B4-BE49-F238E27FC236}">
+                <a16:creationId xmlns:a16="http://schemas.microsoft.com/office/drawing/2014/main" id="{ACB4CDA4-8637-4477-B694-E946B538D626}"/>
+              </a:ext>
+            </a:extLst>
+          </p:cNvPr>
+          <p:cNvSpPr txBox="1"/>
+          <p:nvPr/>
+        </p:nvSpPr>
+        <p:spPr>
+          <a:xfrm>
+            <a:off x="4371681" y="6304763"/>
+            <a:ext cx="946799" cy="288541"/>
+          </a:xfrm>
+          <a:prstGeom prst="rect">
+            <a:avLst/>
+          </a:prstGeom>
+          <a:noFill/>
+        </p:spPr>
+        <p:txBody>
+          <a:bodyPr wrap="none" rtlCol="0">
+            <a:spAutoFit/>
+          </a:bodyPr>
+          <a:lstStyle/>
+          <a:p>
+            <a:pPr algn="ctr"/>
+            <a:r>
+              <a:rPr lang="pt-BR" sz="1275" spc="0" baseline="0" dirty="0">
+                <a:solidFill>
+                  <a:srgbClr val="4D4D4D"/>
+                </a:solidFill>
+                <a:latin typeface="Arial"/>
+                <a:cs typeface="Arial"/>
+                <a:sym typeface="Arial"/>
+                <a:rtl val="0"/>
+              </a:rPr>
+              <a:t>10.10.0.11</a:t>
+            </a:r>
+          </a:p>
+        </p:txBody>
+      </p:sp>
+      <p:pic>
+        <p:nvPicPr>
+          <p:cNvPr id="81" name="Imagem 80">
+            <a:extLst>
+              <a:ext uri="{FF2B5EF4-FFF2-40B4-BE49-F238E27FC236}">
+                <a16:creationId xmlns:a16="http://schemas.microsoft.com/office/drawing/2014/main" id="{54E523FB-5B6D-43BD-A365-B56E4BA58FD8}"/>
+              </a:ext>
+            </a:extLst>
+          </p:cNvPr>
+          <p:cNvPicPr>
+            <a:picLocks noChangeAspect="1"/>
+          </p:cNvPicPr>
+          <p:nvPr/>
+        </p:nvPicPr>
+        <p:blipFill>
+          <a:blip r:embed="rId2"/>
+          <a:stretch>
+            <a:fillRect/>
+          </a:stretch>
+        </p:blipFill>
+        <p:spPr>
+          <a:xfrm>
+            <a:off x="4495313" y="5710691"/>
+            <a:ext cx="699529" cy="594072"/>
+          </a:xfrm>
+          <a:prstGeom prst="rect">
+            <a:avLst/>
+          </a:prstGeom>
+        </p:spPr>
+      </p:pic>
+      <p:sp>
+        <p:nvSpPr>
+          <p:cNvPr id="83" name="CaixaDeTexto 82">
+            <a:extLst>
+              <a:ext uri="{FF2B5EF4-FFF2-40B4-BE49-F238E27FC236}">
+                <a16:creationId xmlns:a16="http://schemas.microsoft.com/office/drawing/2014/main" id="{9E33DE23-2BC3-414C-B08A-54D7CD2CDA81}"/>
+              </a:ext>
+            </a:extLst>
+          </p:cNvPr>
+          <p:cNvSpPr txBox="1"/>
+          <p:nvPr/>
+        </p:nvSpPr>
+        <p:spPr>
+          <a:xfrm>
+            <a:off x="2433245" y="6304763"/>
+            <a:ext cx="958917" cy="288541"/>
+          </a:xfrm>
+          <a:prstGeom prst="rect">
+            <a:avLst/>
+          </a:prstGeom>
+          <a:noFill/>
+        </p:spPr>
+        <p:txBody>
+          <a:bodyPr wrap="none" rtlCol="0">
+            <a:spAutoFit/>
+          </a:bodyPr>
+          <a:lstStyle/>
+          <a:p>
+            <a:pPr algn="ctr"/>
+            <a:r>
+              <a:rPr lang="pt-BR" sz="1275" spc="0" baseline="0" dirty="0">
+                <a:solidFill>
+                  <a:srgbClr val="4D4D4D"/>
+                </a:solidFill>
+                <a:latin typeface="Arial"/>
+                <a:cs typeface="Arial"/>
+                <a:sym typeface="Arial"/>
+                <a:rtl val="0"/>
+              </a:rPr>
+              <a:t>10.10.0.10</a:t>
+            </a:r>
+          </a:p>
+        </p:txBody>
+      </p:sp>
+      <p:pic>
+        <p:nvPicPr>
+          <p:cNvPr id="84" name="Imagem 83">
+            <a:extLst>
+              <a:ext uri="{FF2B5EF4-FFF2-40B4-BE49-F238E27FC236}">
+                <a16:creationId xmlns:a16="http://schemas.microsoft.com/office/drawing/2014/main" id="{1548EDC0-18D1-4AAA-89E7-63EC7FC669E0}"/>
+              </a:ext>
+            </a:extLst>
+          </p:cNvPr>
+          <p:cNvPicPr>
+            <a:picLocks noChangeAspect="1"/>
+          </p:cNvPicPr>
+          <p:nvPr/>
+        </p:nvPicPr>
+        <p:blipFill>
+          <a:blip r:embed="rId2"/>
+          <a:stretch>
+            <a:fillRect/>
+          </a:stretch>
+        </p:blipFill>
+        <p:spPr>
+          <a:xfrm>
+            <a:off x="2562936" y="5710691"/>
+            <a:ext cx="699529" cy="594072"/>
+          </a:xfrm>
+          <a:prstGeom prst="rect">
+            <a:avLst/>
+          </a:prstGeom>
+        </p:spPr>
+      </p:pic>
+      <p:sp>
+        <p:nvSpPr>
+          <p:cNvPr id="89" name="CaixaDeTexto 88">
+            <a:extLst>
+              <a:ext uri="{FF2B5EF4-FFF2-40B4-BE49-F238E27FC236}">
+                <a16:creationId xmlns:a16="http://schemas.microsoft.com/office/drawing/2014/main" id="{6D6F7AD6-A742-406D-A1F6-AB2D0CD6BD1A}"/>
+              </a:ext>
+            </a:extLst>
+          </p:cNvPr>
+          <p:cNvSpPr txBox="1"/>
+          <p:nvPr/>
+        </p:nvSpPr>
+        <p:spPr>
+          <a:xfrm>
+            <a:off x="8230375" y="6304763"/>
+            <a:ext cx="958917" cy="288541"/>
+          </a:xfrm>
+          <a:prstGeom prst="rect">
+            <a:avLst/>
+          </a:prstGeom>
+          <a:noFill/>
+        </p:spPr>
+        <p:txBody>
+          <a:bodyPr wrap="none" rtlCol="0">
+            <a:spAutoFit/>
+          </a:bodyPr>
+          <a:lstStyle/>
+          <a:p>
+            <a:pPr algn="ctr"/>
+            <a:r>
+              <a:rPr lang="pt-BR" sz="1275" spc="0" baseline="0" dirty="0">
+                <a:solidFill>
+                  <a:srgbClr val="4D4D4D"/>
+                </a:solidFill>
+                <a:latin typeface="Arial"/>
+                <a:cs typeface="Arial"/>
+                <a:sym typeface="Arial"/>
+                <a:rtl val="0"/>
+              </a:rPr>
+              <a:t>10.10.0.13</a:t>
+            </a:r>
+          </a:p>
+        </p:txBody>
+      </p:sp>
+      <p:pic>
+        <p:nvPicPr>
+          <p:cNvPr id="90" name="Imagem 89">
+            <a:extLst>
+              <a:ext uri="{FF2B5EF4-FFF2-40B4-BE49-F238E27FC236}">
+                <a16:creationId xmlns:a16="http://schemas.microsoft.com/office/drawing/2014/main" id="{80EEFEF6-40EB-43F5-B6AD-A2889F879971}"/>
+              </a:ext>
+            </a:extLst>
+          </p:cNvPr>
+          <p:cNvPicPr>
+            <a:picLocks noChangeAspect="1"/>
+          </p:cNvPicPr>
+          <p:nvPr/>
+        </p:nvPicPr>
+        <p:blipFill>
+          <a:blip r:embed="rId2"/>
+          <a:stretch>
+            <a:fillRect/>
+          </a:stretch>
+        </p:blipFill>
+        <p:spPr>
+          <a:xfrm>
+            <a:off x="8360066" y="5710691"/>
+            <a:ext cx="699529" cy="594072"/>
+          </a:xfrm>
+          <a:prstGeom prst="rect">
+            <a:avLst/>
+          </a:prstGeom>
+        </p:spPr>
+      </p:pic>
+      <p:sp>
+        <p:nvSpPr>
+          <p:cNvPr id="75" name="CaixaDeTexto 74">
+            <a:extLst>
+              <a:ext uri="{FF2B5EF4-FFF2-40B4-BE49-F238E27FC236}">
+                <a16:creationId xmlns:a16="http://schemas.microsoft.com/office/drawing/2014/main" id="{5BFE0F38-0B16-441D-96C3-E4B1A59F88AC}"/>
+              </a:ext>
+            </a:extLst>
+          </p:cNvPr>
+          <p:cNvSpPr txBox="1"/>
+          <p:nvPr/>
+        </p:nvSpPr>
+        <p:spPr>
+          <a:xfrm>
+            <a:off x="8292637" y="1824677"/>
+            <a:ext cx="1324402" cy="288541"/>
+          </a:xfrm>
+          <a:prstGeom prst="rect">
+            <a:avLst/>
+          </a:prstGeom>
+          <a:noFill/>
+        </p:spPr>
+        <p:txBody>
+          <a:bodyPr wrap="none" rtlCol="0">
+            <a:spAutoFit/>
+          </a:bodyPr>
+          <a:lstStyle/>
+          <a:p>
+            <a:pPr algn="ctr"/>
+            <a:r>
+              <a:rPr lang="pt-BR" sz="1275" spc="0" baseline="0" dirty="0">
+                <a:solidFill>
+                  <a:srgbClr val="8F12B2"/>
+                </a:solidFill>
+                <a:latin typeface="Arial"/>
+                <a:cs typeface="Arial"/>
+                <a:sym typeface="Arial"/>
+                <a:rtl val="0"/>
+              </a:rPr>
+              <a:t>205,251.193.51</a:t>
+            </a:r>
+          </a:p>
+        </p:txBody>
+      </p:sp>
+      <p:pic>
+        <p:nvPicPr>
+          <p:cNvPr id="78" name="Imagem 77">
+            <a:extLst>
+              <a:ext uri="{FF2B5EF4-FFF2-40B4-BE49-F238E27FC236}">
+                <a16:creationId xmlns:a16="http://schemas.microsoft.com/office/drawing/2014/main" id="{A4E2A55C-F5A9-45EE-8160-48687EE03A8C}"/>
+              </a:ext>
+            </a:extLst>
+          </p:cNvPr>
+          <p:cNvPicPr>
+            <a:picLocks noChangeAspect="1"/>
+          </p:cNvPicPr>
+          <p:nvPr/>
+        </p:nvPicPr>
+        <p:blipFill>
+          <a:blip r:embed="rId3"/>
+          <a:stretch>
+            <a:fillRect/>
+          </a:stretch>
+        </p:blipFill>
+        <p:spPr>
+          <a:xfrm>
+            <a:off x="8605073" y="1179454"/>
+            <a:ext cx="699529" cy="590557"/>
+          </a:xfrm>
+          <a:prstGeom prst="rect">
+            <a:avLst/>
+          </a:prstGeom>
+        </p:spPr>
+      </p:pic>
+      <p:sp>
+        <p:nvSpPr>
+          <p:cNvPr id="143" name="CaixaDeTexto 142">
+            <a:extLst>
+              <a:ext uri="{FF2B5EF4-FFF2-40B4-BE49-F238E27FC236}">
+                <a16:creationId xmlns:a16="http://schemas.microsoft.com/office/drawing/2014/main" id="{7DD8A38D-F3D4-4D09-A1A9-BC37DF685D77}"/>
+              </a:ext>
+            </a:extLst>
+          </p:cNvPr>
+          <p:cNvSpPr txBox="1"/>
+          <p:nvPr/>
+        </p:nvSpPr>
+        <p:spPr>
+          <a:xfrm>
+            <a:off x="8292633" y="3066165"/>
+            <a:ext cx="1324402" cy="288541"/>
+          </a:xfrm>
+          <a:prstGeom prst="rect">
+            <a:avLst/>
+          </a:prstGeom>
+          <a:noFill/>
+        </p:spPr>
+        <p:txBody>
+          <a:bodyPr wrap="none" rtlCol="0">
+            <a:spAutoFit/>
+          </a:bodyPr>
+          <a:lstStyle/>
+          <a:p>
+            <a:pPr algn="ctr"/>
+            <a:r>
+              <a:rPr lang="pt-BR" sz="1275" dirty="0">
+                <a:solidFill>
+                  <a:srgbClr val="8F12B2"/>
+                </a:solidFill>
+                <a:latin typeface="Arial"/>
+                <a:cs typeface="Arial"/>
+                <a:sym typeface="Arial"/>
+                <a:rtl val="0"/>
+              </a:rPr>
+              <a:t>205.251.193.50</a:t>
+            </a:r>
+            <a:endParaRPr lang="pt-BR" sz="1275" spc="0" baseline="0" dirty="0">
+              <a:solidFill>
+                <a:srgbClr val="8F12B2"/>
+              </a:solidFill>
+              <a:latin typeface="Arial"/>
+              <a:cs typeface="Arial"/>
+              <a:sym typeface="Arial"/>
+              <a:rtl val="0"/>
+            </a:endParaRPr>
+          </a:p>
+        </p:txBody>
+      </p:sp>
+      <p:pic>
+        <p:nvPicPr>
+          <p:cNvPr id="145" name="Imagem 144">
+            <a:extLst>
+              <a:ext uri="{FF2B5EF4-FFF2-40B4-BE49-F238E27FC236}">
+                <a16:creationId xmlns:a16="http://schemas.microsoft.com/office/drawing/2014/main" id="{DFC32D8D-CE7C-45B7-8C04-9C488BB2532E}"/>
+              </a:ext>
+            </a:extLst>
+          </p:cNvPr>
+          <p:cNvPicPr>
+            <a:picLocks noChangeAspect="1"/>
+          </p:cNvPicPr>
+          <p:nvPr/>
+        </p:nvPicPr>
+        <p:blipFill>
+          <a:blip r:embed="rId3"/>
+          <a:stretch>
+            <a:fillRect/>
+          </a:stretch>
+        </p:blipFill>
+        <p:spPr>
+          <a:xfrm>
+            <a:off x="8605073" y="2420942"/>
+            <a:ext cx="699529" cy="590557"/>
+          </a:xfrm>
+          <a:prstGeom prst="rect">
+            <a:avLst/>
+          </a:prstGeom>
+        </p:spPr>
+      </p:pic>
+      <p:sp>
+        <p:nvSpPr>
+          <p:cNvPr id="148" name="CaixaDeTexto 147">
+            <a:extLst>
+              <a:ext uri="{FF2B5EF4-FFF2-40B4-BE49-F238E27FC236}">
+                <a16:creationId xmlns:a16="http://schemas.microsoft.com/office/drawing/2014/main" id="{B4FE58D5-6C70-4908-97EE-852E11EF2C1A}"/>
+              </a:ext>
+            </a:extLst>
+          </p:cNvPr>
+          <p:cNvSpPr txBox="1"/>
+          <p:nvPr/>
+        </p:nvSpPr>
+        <p:spPr>
+          <a:xfrm>
+            <a:off x="8215024" y="4334621"/>
+            <a:ext cx="1415772" cy="288541"/>
+          </a:xfrm>
+          <a:prstGeom prst="rect">
+            <a:avLst/>
+          </a:prstGeom>
+          <a:noFill/>
+        </p:spPr>
+        <p:txBody>
+          <a:bodyPr wrap="none" rtlCol="0">
+            <a:spAutoFit/>
+          </a:bodyPr>
+          <a:lstStyle/>
+          <a:p>
+            <a:pPr algn="ctr"/>
+            <a:r>
+              <a:rPr lang="pt-BR" sz="1275" dirty="0">
+                <a:solidFill>
+                  <a:srgbClr val="8F12B2"/>
+                </a:solidFill>
+                <a:latin typeface="Arial"/>
+                <a:cs typeface="Arial"/>
+                <a:sym typeface="Arial"/>
+                <a:rtl val="0"/>
+              </a:rPr>
+              <a:t>205.251.193.203</a:t>
+            </a:r>
+          </a:p>
+        </p:txBody>
+      </p:sp>
+      <p:pic>
+        <p:nvPicPr>
+          <p:cNvPr id="150" name="Imagem 149">
+            <a:extLst>
+              <a:ext uri="{FF2B5EF4-FFF2-40B4-BE49-F238E27FC236}">
+                <a16:creationId xmlns:a16="http://schemas.microsoft.com/office/drawing/2014/main" id="{C6877574-FE98-4069-B4B1-BFD2367F1EB1}"/>
+              </a:ext>
+            </a:extLst>
+          </p:cNvPr>
+          <p:cNvPicPr>
+            <a:picLocks noChangeAspect="1"/>
+          </p:cNvPicPr>
+          <p:nvPr/>
+        </p:nvPicPr>
+        <p:blipFill>
+          <a:blip r:embed="rId3"/>
+          <a:stretch>
+            <a:fillRect/>
+          </a:stretch>
+        </p:blipFill>
+        <p:spPr>
+          <a:xfrm>
+            <a:off x="8605073" y="3662429"/>
+            <a:ext cx="699529" cy="590557"/>
+          </a:xfrm>
+          <a:prstGeom prst="rect">
+            <a:avLst/>
+          </a:prstGeom>
+        </p:spPr>
+      </p:pic>
+      <p:pic>
+        <p:nvPicPr>
+          <p:cNvPr id="99" name="Imagem 98">
+            <a:extLst>
+              <a:ext uri="{FF2B5EF4-FFF2-40B4-BE49-F238E27FC236}">
+                <a16:creationId xmlns:a16="http://schemas.microsoft.com/office/drawing/2014/main" id="{135563C5-EE96-4DE3-B6D9-62F988A6EA72}"/>
+              </a:ext>
+            </a:extLst>
+          </p:cNvPr>
+          <p:cNvPicPr>
+            <a:picLocks noChangeAspect="1"/>
+          </p:cNvPicPr>
+          <p:nvPr/>
+        </p:nvPicPr>
+        <p:blipFill>
+          <a:blip r:embed="rId4"/>
+          <a:stretch>
+            <a:fillRect/>
+          </a:stretch>
+        </p:blipFill>
+        <p:spPr>
+          <a:xfrm>
+            <a:off x="6319914" y="3456557"/>
+            <a:ext cx="892147" cy="348630"/>
+          </a:xfrm>
+          <a:prstGeom prst="rect">
+            <a:avLst/>
+          </a:prstGeom>
+        </p:spPr>
+      </p:pic>
+      <p:pic>
+        <p:nvPicPr>
+          <p:cNvPr id="170" name="Imagem 169">
+            <a:extLst>
+              <a:ext uri="{FF2B5EF4-FFF2-40B4-BE49-F238E27FC236}">
+                <a16:creationId xmlns:a16="http://schemas.microsoft.com/office/drawing/2014/main" id="{4FB7C072-315E-49D7-BA5C-C58CE940E2F1}"/>
+              </a:ext>
+            </a:extLst>
+          </p:cNvPr>
+          <p:cNvPicPr>
+            <a:picLocks noChangeAspect="1"/>
+          </p:cNvPicPr>
+          <p:nvPr/>
+        </p:nvPicPr>
+        <p:blipFill>
+          <a:blip r:embed="rId4"/>
+          <a:stretch>
+            <a:fillRect/>
+          </a:stretch>
+        </p:blipFill>
+        <p:spPr>
+          <a:xfrm>
+            <a:off x="6319914" y="4797437"/>
+            <a:ext cx="892147" cy="348630"/>
+          </a:xfrm>
+          <a:prstGeom prst="rect">
+            <a:avLst/>
+          </a:prstGeom>
+        </p:spPr>
+      </p:pic>
+      <p:sp>
+        <p:nvSpPr>
+          <p:cNvPr id="171" name="CaixaDeTexto 170">
+            <a:extLst>
+              <a:ext uri="{FF2B5EF4-FFF2-40B4-BE49-F238E27FC236}">
+                <a16:creationId xmlns:a16="http://schemas.microsoft.com/office/drawing/2014/main" id="{233930AA-DDBD-4AAE-8217-77B215A5B047}"/>
+              </a:ext>
+            </a:extLst>
+          </p:cNvPr>
+          <p:cNvSpPr txBox="1"/>
+          <p:nvPr/>
+        </p:nvSpPr>
+        <p:spPr>
+          <a:xfrm>
+            <a:off x="1405359" y="3146522"/>
+            <a:ext cx="1324402" cy="288541"/>
+          </a:xfrm>
+          <a:prstGeom prst="rect">
+            <a:avLst/>
+          </a:prstGeom>
+          <a:noFill/>
+        </p:spPr>
+        <p:txBody>
+          <a:bodyPr wrap="none" rtlCol="0">
+            <a:spAutoFit/>
+          </a:bodyPr>
+          <a:lstStyle/>
+          <a:p>
+            <a:pPr algn="ctr"/>
+            <a:r>
+              <a:rPr lang="pt-BR" sz="1275" spc="0" baseline="0" dirty="0">
+                <a:solidFill>
+                  <a:srgbClr val="8F12B2"/>
+                </a:solidFill>
+                <a:latin typeface="Arial"/>
+                <a:cs typeface="Arial"/>
+                <a:sym typeface="Arial"/>
+                <a:rtl val="0"/>
+              </a:rPr>
+              <a:t>205.251.10.147</a:t>
+            </a:r>
+          </a:p>
+        </p:txBody>
+      </p:sp>
+      <p:pic>
+        <p:nvPicPr>
+          <p:cNvPr id="173" name="Imagem 172">
+            <a:extLst>
+              <a:ext uri="{FF2B5EF4-FFF2-40B4-BE49-F238E27FC236}">
+                <a16:creationId xmlns:a16="http://schemas.microsoft.com/office/drawing/2014/main" id="{C2B85396-F81D-46C7-B3A7-C0948B6486B2}"/>
+              </a:ext>
+            </a:extLst>
+          </p:cNvPr>
+          <p:cNvPicPr>
+            <a:picLocks noChangeAspect="1"/>
+          </p:cNvPicPr>
+          <p:nvPr/>
+        </p:nvPicPr>
+        <p:blipFill>
+          <a:blip r:embed="rId3"/>
+          <a:stretch>
+            <a:fillRect/>
+          </a:stretch>
+        </p:blipFill>
+        <p:spPr>
+          <a:xfrm>
+            <a:off x="1717795" y="2501299"/>
+            <a:ext cx="699529" cy="590557"/>
+          </a:xfrm>
+          <a:prstGeom prst="rect">
+            <a:avLst/>
+          </a:prstGeom>
+        </p:spPr>
+      </p:pic>
+      <p:sp>
+        <p:nvSpPr>
+          <p:cNvPr id="180" name="CaixaDeTexto 179">
+            <a:extLst>
+              <a:ext uri="{FF2B5EF4-FFF2-40B4-BE49-F238E27FC236}">
+                <a16:creationId xmlns:a16="http://schemas.microsoft.com/office/drawing/2014/main" id="{1C803C71-8E33-4C90-80F0-81B66A97BC5A}"/>
+              </a:ext>
+            </a:extLst>
+          </p:cNvPr>
+          <p:cNvSpPr txBox="1"/>
+          <p:nvPr/>
+        </p:nvSpPr>
+        <p:spPr>
+          <a:xfrm>
+            <a:off x="1451040" y="4447539"/>
+            <a:ext cx="1233031" cy="288541"/>
+          </a:xfrm>
+          <a:prstGeom prst="rect">
+            <a:avLst/>
+          </a:prstGeom>
+          <a:noFill/>
+        </p:spPr>
+        <p:txBody>
+          <a:bodyPr wrap="none" rtlCol="0">
+            <a:spAutoFit/>
+          </a:bodyPr>
+          <a:lstStyle/>
+          <a:p>
+            <a:pPr algn="ctr"/>
+            <a:r>
+              <a:rPr lang="pt-BR" sz="1275" dirty="0">
+                <a:solidFill>
+                  <a:srgbClr val="8F12B2"/>
+                </a:solidFill>
+                <a:latin typeface="Arial"/>
+                <a:cs typeface="Arial"/>
+                <a:sym typeface="Arial"/>
+                <a:rtl val="0"/>
+              </a:rPr>
+              <a:t>205.251.10.82</a:t>
+            </a:r>
+            <a:endParaRPr lang="pt-BR" sz="1275" spc="0" baseline="0" dirty="0">
+              <a:solidFill>
+                <a:srgbClr val="8F12B2"/>
+              </a:solidFill>
+              <a:latin typeface="Arial"/>
+              <a:cs typeface="Arial"/>
+              <a:sym typeface="Arial"/>
+              <a:rtl val="0"/>
+            </a:endParaRPr>
+          </a:p>
+        </p:txBody>
+      </p:sp>
+      <p:pic>
+        <p:nvPicPr>
+          <p:cNvPr id="182" name="Imagem 181">
+            <a:extLst>
+              <a:ext uri="{FF2B5EF4-FFF2-40B4-BE49-F238E27FC236}">
+                <a16:creationId xmlns:a16="http://schemas.microsoft.com/office/drawing/2014/main" id="{CFFA14DF-95C5-400E-9350-9A27DB736762}"/>
+              </a:ext>
+            </a:extLst>
+          </p:cNvPr>
+          <p:cNvPicPr>
+            <a:picLocks noChangeAspect="1"/>
+          </p:cNvPicPr>
+          <p:nvPr/>
+        </p:nvPicPr>
+        <p:blipFill>
+          <a:blip r:embed="rId3"/>
+          <a:stretch>
+            <a:fillRect/>
+          </a:stretch>
+        </p:blipFill>
+        <p:spPr>
+          <a:xfrm>
+            <a:off x="1717795" y="3802316"/>
+            <a:ext cx="699529" cy="590557"/>
+          </a:xfrm>
+          <a:prstGeom prst="rect">
+            <a:avLst/>
+          </a:prstGeom>
+        </p:spPr>
+      </p:pic>
+      <p:pic>
+        <p:nvPicPr>
+          <p:cNvPr id="184" name="Imagem 183">
+            <a:extLst>
+              <a:ext uri="{FF2B5EF4-FFF2-40B4-BE49-F238E27FC236}">
+                <a16:creationId xmlns:a16="http://schemas.microsoft.com/office/drawing/2014/main" id="{497D8254-A29B-46BC-818E-CA5954FAD00A}"/>
+              </a:ext>
+            </a:extLst>
+          </p:cNvPr>
+          <p:cNvPicPr>
+            <a:picLocks noChangeAspect="1"/>
+          </p:cNvPicPr>
+          <p:nvPr/>
+        </p:nvPicPr>
+        <p:blipFill>
+          <a:blip r:embed="rId4"/>
+          <a:stretch>
+            <a:fillRect/>
+          </a:stretch>
+        </p:blipFill>
+        <p:spPr>
+          <a:xfrm>
+            <a:off x="3454748" y="3456557"/>
+            <a:ext cx="892147" cy="348630"/>
+          </a:xfrm>
+          <a:prstGeom prst="rect">
+            <a:avLst/>
+          </a:prstGeom>
+        </p:spPr>
+      </p:pic>
+      <p:pic>
+        <p:nvPicPr>
+          <p:cNvPr id="192" name="Imagem 191">
+            <a:extLst>
+              <a:ext uri="{FF2B5EF4-FFF2-40B4-BE49-F238E27FC236}">
+                <a16:creationId xmlns:a16="http://schemas.microsoft.com/office/drawing/2014/main" id="{6FBDDE80-C632-493C-AA6C-411CD9C107AF}"/>
+              </a:ext>
+            </a:extLst>
+          </p:cNvPr>
+          <p:cNvPicPr>
+            <a:picLocks noChangeAspect="1"/>
+          </p:cNvPicPr>
+          <p:nvPr/>
+        </p:nvPicPr>
+        <p:blipFill>
+          <a:blip r:embed="rId5"/>
+          <a:stretch>
+            <a:fillRect/>
+          </a:stretch>
+        </p:blipFill>
+        <p:spPr>
+          <a:xfrm>
+            <a:off x="5194125" y="1391903"/>
+            <a:ext cx="540349" cy="935726"/>
+          </a:xfrm>
+          <a:prstGeom prst="rect">
+            <a:avLst/>
+          </a:prstGeom>
+        </p:spPr>
+      </p:pic>
+      <p:grpSp>
+        <p:nvGrpSpPr>
+          <p:cNvPr id="228" name="Agrupar 227">
+            <a:extLst>
+              <a:ext uri="{FF2B5EF4-FFF2-40B4-BE49-F238E27FC236}">
+                <a16:creationId xmlns:a16="http://schemas.microsoft.com/office/drawing/2014/main" id="{FFDC00A4-134D-4A8C-B437-6BC9AD02BE15}"/>
+              </a:ext>
+            </a:extLst>
+          </p:cNvPr>
+          <p:cNvGrpSpPr/>
+          <p:nvPr/>
+        </p:nvGrpSpPr>
+        <p:grpSpPr>
+          <a:xfrm>
+            <a:off x="6587559" y="58892"/>
+            <a:ext cx="975074" cy="645586"/>
+            <a:chOff x="7075096" y="-1400689"/>
+            <a:chExt cx="975074" cy="645586"/>
+          </a:xfrm>
+        </p:grpSpPr>
+        <p:sp>
+          <p:nvSpPr>
+            <p:cNvPr id="214" name="Forma Livre: Forma 213">
+              <a:extLst>
+                <a:ext uri="{FF2B5EF4-FFF2-40B4-BE49-F238E27FC236}">
+                  <a16:creationId xmlns:a16="http://schemas.microsoft.com/office/drawing/2014/main" id="{65C1B55D-D085-4D5F-B9D0-C5E402F7CB24}"/>
+                </a:ext>
+              </a:extLst>
+            </p:cNvPr>
+            <p:cNvSpPr/>
+            <p:nvPr/>
+          </p:nvSpPr>
+          <p:spPr>
+            <a:xfrm>
+              <a:off x="7075096" y="-1400689"/>
+              <a:ext cx="975074" cy="645586"/>
+            </a:xfrm>
+            <a:custGeom>
+              <a:avLst/>
+              <a:gdLst>
+                <a:gd name="connsiteX0" fmla="*/ 592200 w 650049"/>
+                <a:gd name="connsiteY0" fmla="*/ 232222 h 430391"/>
+                <a:gd name="connsiteX1" fmla="*/ 593495 w 650049"/>
+                <a:gd name="connsiteY1" fmla="*/ 215721 h 430391"/>
+                <a:gd name="connsiteX2" fmla="*/ 482304 w 650049"/>
+                <a:gd name="connsiteY2" fmla="*/ 102859 h 430391"/>
+                <a:gd name="connsiteX3" fmla="*/ 361634 w 650049"/>
+                <a:gd name="connsiteY3" fmla="*/ 376 h 430391"/>
+                <a:gd name="connsiteX4" fmla="*/ 263752 w 650049"/>
+                <a:gd name="connsiteY4" fmla="*/ 78971 h 430391"/>
+                <a:gd name="connsiteX5" fmla="*/ 76928 w 650049"/>
+                <a:gd name="connsiteY5" fmla="*/ 197315 h 430391"/>
+                <a:gd name="connsiteX6" fmla="*/ 73239 w 650049"/>
+                <a:gd name="connsiteY6" fmla="*/ 225805 h 430391"/>
+                <a:gd name="connsiteX7" fmla="*/ 4880 w 650049"/>
+                <a:gd name="connsiteY7" fmla="*/ 357181 h 430391"/>
+                <a:gd name="connsiteX8" fmla="*/ 104838 w 650049"/>
+                <a:gd name="connsiteY8" fmla="*/ 430391 h 430391"/>
+                <a:gd name="connsiteX9" fmla="*/ 545341 w 650049"/>
+                <a:gd name="connsiteY9" fmla="*/ 430391 h 430391"/>
+                <a:gd name="connsiteX10" fmla="*/ 650050 w 650049"/>
+                <a:gd name="connsiteY10" fmla="*/ 325769 h 430391"/>
+                <a:gd name="connsiteX11" fmla="*/ 592416 w 650049"/>
+                <a:gd name="connsiteY11" fmla="*/ 232222 h 430391"/>
+              </a:gdLst>
+              <a:ahLst/>
+              <a:cxnLst>
+                <a:cxn ang="0">
+                  <a:pos x="connsiteX0" y="connsiteY0"/>
+                </a:cxn>
+                <a:cxn ang="0">
+                  <a:pos x="connsiteX1" y="connsiteY1"/>
+                </a:cxn>
+                <a:cxn ang="0">
+                  <a:pos x="connsiteX2" y="connsiteY2"/>
+                </a:cxn>
+                <a:cxn ang="0">
+                  <a:pos x="connsiteX3" y="connsiteY3"/>
+                </a:cxn>
+                <a:cxn ang="0">
+                  <a:pos x="connsiteX4" y="connsiteY4"/>
+                </a:cxn>
+                <a:cxn ang="0">
+                  <a:pos x="connsiteX5" y="connsiteY5"/>
+                </a:cxn>
+                <a:cxn ang="0">
+                  <a:pos x="connsiteX6" y="connsiteY6"/>
+                </a:cxn>
+                <a:cxn ang="0">
+                  <a:pos x="connsiteX7" y="connsiteY7"/>
+                </a:cxn>
+                <a:cxn ang="0">
+                  <a:pos x="connsiteX8" y="connsiteY8"/>
+                </a:cxn>
+                <a:cxn ang="0">
+                  <a:pos x="connsiteX9" y="connsiteY9"/>
+                </a:cxn>
+                <a:cxn ang="0">
+                  <a:pos x="connsiteX10" y="connsiteY10"/>
+                </a:cxn>
+                <a:cxn ang="0">
+                  <a:pos x="connsiteX11" y="connsiteY11"/>
+                </a:cxn>
+              </a:cxnLst>
+              <a:rect l="l" t="t" r="r" b="b"/>
+              <a:pathLst>
+                <a:path w="650049" h="430391">
+                  <a:moveTo>
+                    <a:pt x="592200" y="232222"/>
+                  </a:moveTo>
+                  <a:cubicBezTo>
+                    <a:pt x="593015" y="226758"/>
+                    <a:pt x="593446" y="221245"/>
+                    <a:pt x="593495" y="215721"/>
+                  </a:cubicBezTo>
+                  <a:cubicBezTo>
+                    <a:pt x="593500" y="154036"/>
+                    <a:pt x="543982" y="103772"/>
+                    <a:pt x="482304" y="102859"/>
+                  </a:cubicBezTo>
+                  <a:cubicBezTo>
+                    <a:pt x="477284" y="41238"/>
+                    <a:pt x="423258" y="-4646"/>
+                    <a:pt x="361634" y="376"/>
+                  </a:cubicBezTo>
+                  <a:cubicBezTo>
+                    <a:pt x="316009" y="4094"/>
+                    <a:pt x="277238" y="35222"/>
+                    <a:pt x="263752" y="78971"/>
+                  </a:cubicBezTo>
+                  <a:cubicBezTo>
+                    <a:pt x="179480" y="60061"/>
+                    <a:pt x="95839" y="113046"/>
+                    <a:pt x="76928" y="197315"/>
+                  </a:cubicBezTo>
+                  <a:cubicBezTo>
+                    <a:pt x="74825" y="206679"/>
+                    <a:pt x="73590" y="216216"/>
+                    <a:pt x="73239" y="225805"/>
+                  </a:cubicBezTo>
+                  <a:cubicBezTo>
+                    <a:pt x="18086" y="243207"/>
+                    <a:pt x="-12521" y="302026"/>
+                    <a:pt x="4880" y="357181"/>
+                  </a:cubicBezTo>
+                  <a:cubicBezTo>
+                    <a:pt x="18642" y="400792"/>
+                    <a:pt x="59111" y="430429"/>
+                    <a:pt x="104838" y="430391"/>
+                  </a:cubicBezTo>
+                  <a:lnTo>
+                    <a:pt x="545341" y="430391"/>
+                  </a:lnTo>
+                  <a:cubicBezTo>
+                    <a:pt x="603147" y="430413"/>
+                    <a:pt x="650028" y="383575"/>
+                    <a:pt x="650050" y="325769"/>
+                  </a:cubicBezTo>
+                  <a:cubicBezTo>
+                    <a:pt x="650066" y="286199"/>
+                    <a:pt x="627769" y="250003"/>
+                    <a:pt x="592416" y="232222"/>
+                  </a:cubicBezTo>
+                  <a:close/>
+                </a:path>
+              </a:pathLst>
+            </a:custGeom>
+            <a:solidFill>
+              <a:schemeClr val="bg1">
+                <a:lumMod val="65000"/>
+              </a:schemeClr>
+            </a:solidFill>
+            <a:ln w="5390" cap="flat">
+              <a:noFill/>
+              <a:prstDash val="solid"/>
+              <a:miter/>
+            </a:ln>
+          </p:spPr>
+          <p:txBody>
+            <a:bodyPr rtlCol="0" anchor="ctr"/>
+            <a:lstStyle/>
+            <a:p>
+              <a:endParaRPr lang="pt-BR" sz="3200"/>
+            </a:p>
+          </p:txBody>
+        </p:sp>
+        <p:sp>
+          <p:nvSpPr>
+            <p:cNvPr id="215" name="CaixaDeTexto 214">
+              <a:extLst>
+                <a:ext uri="{FF2B5EF4-FFF2-40B4-BE49-F238E27FC236}">
+                  <a16:creationId xmlns:a16="http://schemas.microsoft.com/office/drawing/2014/main" id="{D34BE052-2791-4802-BABC-6AD760CA775F}"/>
+                </a:ext>
+              </a:extLst>
+            </p:cNvPr>
+            <p:cNvSpPr txBox="1"/>
+            <p:nvPr/>
+          </p:nvSpPr>
+          <p:spPr>
+            <a:xfrm>
+              <a:off x="7213819" y="-1156482"/>
+              <a:ext cx="697627" cy="215444"/>
+            </a:xfrm>
+            <a:prstGeom prst="rect">
+              <a:avLst/>
+            </a:prstGeom>
+            <a:noFill/>
+          </p:spPr>
+          <p:txBody>
+            <a:bodyPr wrap="none" rtlCol="0">
+              <a:spAutoFit/>
+            </a:bodyPr>
+            <a:lstStyle/>
+            <a:p>
+              <a:pPr algn="l"/>
+              <a:r>
+                <a:rPr lang="pt-BR" sz="800" b="1" spc="0" baseline="0" dirty="0">
+                  <a:solidFill>
+                    <a:schemeClr val="tx1">
+                      <a:lumMod val="85000"/>
+                      <a:lumOff val="15000"/>
+                    </a:schemeClr>
+                  </a:solidFill>
+                  <a:latin typeface="Arial"/>
+                  <a:cs typeface="Arial"/>
+                  <a:sym typeface="Arial"/>
+                  <a:rtl val="0"/>
+                </a:rPr>
+                <a:t>INTERNET</a:t>
+              </a:r>
+            </a:p>
+          </p:txBody>
+        </p:sp>
+        <p:sp>
+          <p:nvSpPr>
+            <p:cNvPr id="216" name="Forma Livre: Forma 215">
+              <a:extLst>
+                <a:ext uri="{FF2B5EF4-FFF2-40B4-BE49-F238E27FC236}">
+                  <a16:creationId xmlns:a16="http://schemas.microsoft.com/office/drawing/2014/main" id="{68919581-5397-4218-93BE-568116742B84}"/>
+                </a:ext>
+              </a:extLst>
+            </p:cNvPr>
+            <p:cNvSpPr/>
+            <p:nvPr/>
+          </p:nvSpPr>
+          <p:spPr>
+            <a:xfrm>
+              <a:off x="7391100" y="-970293"/>
+              <a:ext cx="8843" cy="6201"/>
+            </a:xfrm>
+            <a:custGeom>
+              <a:avLst/>
+              <a:gdLst>
+                <a:gd name="connsiteX0" fmla="*/ 0 w 8843"/>
+                <a:gd name="connsiteY0" fmla="*/ 6201 h 6201"/>
+                <a:gd name="connsiteX1" fmla="*/ 8843 w 8843"/>
+                <a:gd name="connsiteY1" fmla="*/ 0 h 6201"/>
+              </a:gdLst>
+              <a:ahLst/>
+              <a:cxnLst>
+                <a:cxn ang="0">
+                  <a:pos x="connsiteX0" y="connsiteY0"/>
+                </a:cxn>
+                <a:cxn ang="0">
+                  <a:pos x="connsiteX1" y="connsiteY1"/>
+                </a:cxn>
+              </a:cxnLst>
+              <a:rect l="l" t="t" r="r" b="b"/>
+              <a:pathLst>
+                <a:path w="8843" h="6201">
+                  <a:moveTo>
+                    <a:pt x="0" y="6201"/>
+                  </a:moveTo>
+                  <a:lnTo>
+                    <a:pt x="8843" y="0"/>
+                  </a:lnTo>
+                </a:path>
+              </a:pathLst>
+            </a:custGeom>
+            <a:ln w="10779" cap="flat">
+              <a:solidFill>
+                <a:srgbClr val="808080"/>
+              </a:solidFill>
+              <a:prstDash val="solid"/>
+              <a:miter/>
+            </a:ln>
+          </p:spPr>
+          <p:txBody>
+            <a:bodyPr rtlCol="0" anchor="ctr"/>
+            <a:lstStyle/>
+            <a:p>
+              <a:endParaRPr lang="pt-BR"/>
+            </a:p>
+          </p:txBody>
+        </p:sp>
+      </p:grpSp>
+      <p:pic>
+        <p:nvPicPr>
+          <p:cNvPr id="220" name="Imagem 219">
+            <a:extLst>
+              <a:ext uri="{FF2B5EF4-FFF2-40B4-BE49-F238E27FC236}">
+                <a16:creationId xmlns:a16="http://schemas.microsoft.com/office/drawing/2014/main" id="{A944BEC9-3AB1-47EC-864A-1A095183C454}"/>
+              </a:ext>
+            </a:extLst>
+          </p:cNvPr>
+          <p:cNvPicPr>
+            <a:picLocks noChangeAspect="1"/>
+          </p:cNvPicPr>
+          <p:nvPr/>
+        </p:nvPicPr>
+        <p:blipFill>
+          <a:blip r:embed="rId6"/>
+          <a:stretch>
+            <a:fillRect/>
+          </a:stretch>
+        </p:blipFill>
+        <p:spPr>
+          <a:xfrm>
+            <a:off x="5194125" y="533978"/>
+            <a:ext cx="540349" cy="439034"/>
+          </a:xfrm>
+          <a:prstGeom prst="rect">
+            <a:avLst/>
+          </a:prstGeom>
+        </p:spPr>
+      </p:pic>
+      <p:pic>
+        <p:nvPicPr>
+          <p:cNvPr id="231" name="Imagem 230">
+            <a:extLst>
+              <a:ext uri="{FF2B5EF4-FFF2-40B4-BE49-F238E27FC236}">
+                <a16:creationId xmlns:a16="http://schemas.microsoft.com/office/drawing/2014/main" id="{FC4E0A5C-817C-44F1-9301-675B779073E8}"/>
+              </a:ext>
+            </a:extLst>
+          </p:cNvPr>
+          <p:cNvPicPr>
+            <a:picLocks noChangeAspect="1"/>
+          </p:cNvPicPr>
+          <p:nvPr/>
+        </p:nvPicPr>
+        <p:blipFill>
+          <a:blip r:embed="rId6"/>
+          <a:stretch>
+            <a:fillRect/>
+          </a:stretch>
+        </p:blipFill>
+        <p:spPr>
+          <a:xfrm>
+            <a:off x="5194125" y="2746521"/>
+            <a:ext cx="540349" cy="439034"/>
+          </a:xfrm>
+          <a:prstGeom prst="rect">
+            <a:avLst/>
+          </a:prstGeom>
+        </p:spPr>
+      </p:pic>
+      <p:cxnSp>
+        <p:nvCxnSpPr>
+          <p:cNvPr id="232" name="Conector: Angulado 231">
+            <a:extLst>
+              <a:ext uri="{FF2B5EF4-FFF2-40B4-BE49-F238E27FC236}">
+                <a16:creationId xmlns:a16="http://schemas.microsoft.com/office/drawing/2014/main" id="{4DB692BA-332A-4C9E-887E-710B9CEF6FF4}"/>
+              </a:ext>
+            </a:extLst>
+          </p:cNvPr>
+          <p:cNvCxnSpPr>
+            <a:cxnSpLocks/>
+            <a:stCxn id="184" idx="1"/>
+            <a:endCxn id="173" idx="3"/>
+          </p:cNvCxnSpPr>
+          <p:nvPr/>
+        </p:nvCxnSpPr>
+        <p:spPr>
+          <a:xfrm rot="10800000">
+            <a:off x="2417324" y="2796578"/>
+            <a:ext cx="1037424" cy="834294"/>
+          </a:xfrm>
+          <a:prstGeom prst="bentConnector3">
+            <a:avLst/>
+          </a:prstGeom>
+          <a:ln>
+            <a:solidFill>
+              <a:srgbClr val="FF0000"/>
+            </a:solidFill>
+          </a:ln>
+        </p:spPr>
+        <p:style>
+          <a:lnRef idx="1">
+            <a:schemeClr val="accent1"/>
+          </a:lnRef>
+          <a:fillRef idx="0">
+            <a:schemeClr val="accent1"/>
+          </a:fillRef>
+          <a:effectRef idx="0">
+            <a:schemeClr val="accent1"/>
+          </a:effectRef>
+          <a:fontRef idx="minor">
+            <a:schemeClr val="tx1"/>
+          </a:fontRef>
+        </p:style>
+      </p:cxnSp>
+      <p:cxnSp>
+        <p:nvCxnSpPr>
+          <p:cNvPr id="235" name="Conector: Angulado 234">
+            <a:extLst>
+              <a:ext uri="{FF2B5EF4-FFF2-40B4-BE49-F238E27FC236}">
+                <a16:creationId xmlns:a16="http://schemas.microsoft.com/office/drawing/2014/main" id="{E4171E58-04C7-420D-8B24-F2F6C2AB7BB2}"/>
+              </a:ext>
+            </a:extLst>
+          </p:cNvPr>
+          <p:cNvCxnSpPr>
+            <a:stCxn id="182" idx="3"/>
+            <a:endCxn id="184" idx="1"/>
+          </p:cNvCxnSpPr>
+          <p:nvPr/>
+        </p:nvCxnSpPr>
+        <p:spPr>
+          <a:xfrm flipV="1">
+            <a:off x="2417324" y="3630872"/>
+            <a:ext cx="1037424" cy="466723"/>
+          </a:xfrm>
+          <a:prstGeom prst="bentConnector3">
+            <a:avLst>
+              <a:gd name="adj1" fmla="val 49847"/>
+            </a:avLst>
+          </a:prstGeom>
+          <a:ln>
+            <a:solidFill>
+              <a:srgbClr val="FF0000"/>
+            </a:solidFill>
+          </a:ln>
+        </p:spPr>
+        <p:style>
+          <a:lnRef idx="1">
+            <a:schemeClr val="accent1"/>
+          </a:lnRef>
+          <a:fillRef idx="0">
+            <a:schemeClr val="accent1"/>
+          </a:fillRef>
+          <a:effectRef idx="0">
+            <a:schemeClr val="accent1"/>
+          </a:effectRef>
+          <a:fontRef idx="minor">
+            <a:schemeClr val="tx1"/>
+          </a:fontRef>
+        </p:style>
+      </p:cxnSp>
+      <p:cxnSp>
+        <p:nvCxnSpPr>
+          <p:cNvPr id="238" name="Conector reto 237">
+            <a:extLst>
+              <a:ext uri="{FF2B5EF4-FFF2-40B4-BE49-F238E27FC236}">
+                <a16:creationId xmlns:a16="http://schemas.microsoft.com/office/drawing/2014/main" id="{8C5DF1D6-BC05-4073-B09E-3AC66B0589B7}"/>
+              </a:ext>
+            </a:extLst>
+          </p:cNvPr>
+          <p:cNvCxnSpPr>
+            <a:cxnSpLocks/>
+          </p:cNvCxnSpPr>
+          <p:nvPr/>
+        </p:nvCxnSpPr>
+        <p:spPr>
+          <a:xfrm flipV="1">
+            <a:off x="4315504" y="2966038"/>
+            <a:ext cx="870990" cy="510588"/>
+          </a:xfrm>
+          <a:prstGeom prst="line">
+            <a:avLst/>
+          </a:prstGeom>
+          <a:ln>
+            <a:solidFill>
+              <a:srgbClr val="FF0000"/>
+            </a:solidFill>
+          </a:ln>
+        </p:spPr>
+        <p:style>
+          <a:lnRef idx="1">
+            <a:schemeClr val="accent1"/>
+          </a:lnRef>
+          <a:fillRef idx="0">
+            <a:schemeClr val="accent1"/>
+          </a:fillRef>
+          <a:effectRef idx="0">
+            <a:schemeClr val="accent1"/>
+          </a:effectRef>
+          <a:fontRef idx="minor">
+            <a:schemeClr val="tx1"/>
+          </a:fontRef>
+        </p:style>
+      </p:cxnSp>
+      <p:cxnSp>
+        <p:nvCxnSpPr>
+          <p:cNvPr id="240" name="Conector: Angulado 239">
+            <a:extLst>
+              <a:ext uri="{FF2B5EF4-FFF2-40B4-BE49-F238E27FC236}">
+                <a16:creationId xmlns:a16="http://schemas.microsoft.com/office/drawing/2014/main" id="{093CF6CF-6A33-425B-A4AF-5349558423CB}"/>
+              </a:ext>
+            </a:extLst>
+          </p:cNvPr>
+          <p:cNvCxnSpPr>
+            <a:stCxn id="99" idx="3"/>
+            <a:endCxn id="78" idx="1"/>
+          </p:cNvCxnSpPr>
+          <p:nvPr/>
+        </p:nvCxnSpPr>
+        <p:spPr>
+          <a:xfrm flipV="1">
+            <a:off x="7212061" y="1474733"/>
+            <a:ext cx="1393012" cy="2156139"/>
+          </a:xfrm>
+          <a:prstGeom prst="bentConnector3">
+            <a:avLst/>
+          </a:prstGeom>
+          <a:ln>
+            <a:solidFill>
+              <a:srgbClr val="FF0000"/>
+            </a:solidFill>
+          </a:ln>
+        </p:spPr>
+        <p:style>
+          <a:lnRef idx="1">
+            <a:schemeClr val="accent1"/>
+          </a:lnRef>
+          <a:fillRef idx="0">
+            <a:schemeClr val="accent1"/>
+          </a:fillRef>
+          <a:effectRef idx="0">
+            <a:schemeClr val="accent1"/>
+          </a:effectRef>
+          <a:fontRef idx="minor">
+            <a:schemeClr val="tx1"/>
+          </a:fontRef>
+        </p:style>
+      </p:cxnSp>
+      <p:cxnSp>
+        <p:nvCxnSpPr>
+          <p:cNvPr id="242" name="Conector: Angulado 241">
+            <a:extLst>
+              <a:ext uri="{FF2B5EF4-FFF2-40B4-BE49-F238E27FC236}">
+                <a16:creationId xmlns:a16="http://schemas.microsoft.com/office/drawing/2014/main" id="{2E8E5F5C-3B40-4B97-BF3A-FEC8D2D15FE0}"/>
+              </a:ext>
+            </a:extLst>
+          </p:cNvPr>
+          <p:cNvCxnSpPr>
+            <a:stCxn id="99" idx="3"/>
+            <a:endCxn id="150" idx="1"/>
+          </p:cNvCxnSpPr>
+          <p:nvPr/>
+        </p:nvCxnSpPr>
+        <p:spPr>
+          <a:xfrm>
+            <a:off x="7212061" y="3630872"/>
+            <a:ext cx="1393012" cy="326836"/>
+          </a:xfrm>
+          <a:prstGeom prst="bentConnector3">
+            <a:avLst/>
+          </a:prstGeom>
+          <a:ln>
+            <a:solidFill>
+              <a:srgbClr val="FF0000"/>
+            </a:solidFill>
+          </a:ln>
+        </p:spPr>
+        <p:style>
+          <a:lnRef idx="1">
+            <a:schemeClr val="accent1"/>
+          </a:lnRef>
+          <a:fillRef idx="0">
+            <a:schemeClr val="accent1"/>
+          </a:fillRef>
+          <a:effectRef idx="0">
+            <a:schemeClr val="accent1"/>
+          </a:effectRef>
+          <a:fontRef idx="minor">
+            <a:schemeClr val="tx1"/>
+          </a:fontRef>
+        </p:style>
+      </p:cxnSp>
+      <p:cxnSp>
+        <p:nvCxnSpPr>
+          <p:cNvPr id="244" name="Conector reto 243">
+            <a:extLst>
+              <a:ext uri="{FF2B5EF4-FFF2-40B4-BE49-F238E27FC236}">
+                <a16:creationId xmlns:a16="http://schemas.microsoft.com/office/drawing/2014/main" id="{0972B6B3-1F54-4547-876D-C76BEFFE0E42}"/>
+              </a:ext>
+            </a:extLst>
+          </p:cNvPr>
+          <p:cNvCxnSpPr>
+            <a:stCxn id="145" idx="1"/>
+          </p:cNvCxnSpPr>
+          <p:nvPr/>
+        </p:nvCxnSpPr>
+        <p:spPr>
+          <a:xfrm flipH="1" flipV="1">
+            <a:off x="7908567" y="2713444"/>
+            <a:ext cx="696506" cy="0"/>
+          </a:xfrm>
+          <a:prstGeom prst="line">
+            <a:avLst/>
+          </a:prstGeom>
+          <a:ln>
+            <a:solidFill>
+              <a:srgbClr val="FF0000"/>
+            </a:solidFill>
+          </a:ln>
+        </p:spPr>
+        <p:style>
+          <a:lnRef idx="1">
+            <a:schemeClr val="accent1"/>
+          </a:lnRef>
+          <a:fillRef idx="0">
+            <a:schemeClr val="accent1"/>
+          </a:fillRef>
+          <a:effectRef idx="0">
+            <a:schemeClr val="accent1"/>
+          </a:effectRef>
+          <a:fontRef idx="minor">
+            <a:schemeClr val="tx1"/>
+          </a:fontRef>
+        </p:style>
+      </p:cxnSp>
+      <p:cxnSp>
+        <p:nvCxnSpPr>
+          <p:cNvPr id="2049" name="Conector: Angulado 2048">
+            <a:extLst>
+              <a:ext uri="{FF2B5EF4-FFF2-40B4-BE49-F238E27FC236}">
+                <a16:creationId xmlns:a16="http://schemas.microsoft.com/office/drawing/2014/main" id="{2C2FDA28-E29E-4917-A08F-5503CCAD2AD9}"/>
+              </a:ext>
+            </a:extLst>
+          </p:cNvPr>
+          <p:cNvCxnSpPr>
+            <a:cxnSpLocks/>
+            <a:stCxn id="81" idx="0"/>
+            <a:endCxn id="170" idx="2"/>
+          </p:cNvCxnSpPr>
+          <p:nvPr/>
+        </p:nvCxnSpPr>
+        <p:spPr>
+          <a:xfrm rot="5400000" flipH="1" flipV="1">
+            <a:off x="5523221" y="4467924"/>
+            <a:ext cx="564624" cy="1920910"/>
+          </a:xfrm>
+          <a:prstGeom prst="bentConnector3">
+            <a:avLst/>
+          </a:prstGeom>
+          <a:ln>
+            <a:solidFill>
+              <a:srgbClr val="FF0000"/>
+            </a:solidFill>
+          </a:ln>
+        </p:spPr>
+        <p:style>
+          <a:lnRef idx="1">
+            <a:schemeClr val="accent1"/>
+          </a:lnRef>
+          <a:fillRef idx="0">
+            <a:schemeClr val="accent1"/>
+          </a:fillRef>
+          <a:effectRef idx="0">
+            <a:schemeClr val="accent1"/>
+          </a:effectRef>
+          <a:fontRef idx="minor">
+            <a:schemeClr val="tx1"/>
+          </a:fontRef>
+        </p:style>
+      </p:cxnSp>
+      <p:cxnSp>
+        <p:nvCxnSpPr>
+          <p:cNvPr id="2055" name="Conector reto 2054">
+            <a:extLst>
+              <a:ext uri="{FF2B5EF4-FFF2-40B4-BE49-F238E27FC236}">
+                <a16:creationId xmlns:a16="http://schemas.microsoft.com/office/drawing/2014/main" id="{60AF5ED3-E2F6-47DC-9EF8-0B4E6CA72848}"/>
+              </a:ext>
+            </a:extLst>
+          </p:cNvPr>
+          <p:cNvCxnSpPr>
+            <a:stCxn id="170" idx="2"/>
+            <a:endCxn id="2" idx="0"/>
+          </p:cNvCxnSpPr>
+          <p:nvPr/>
+        </p:nvCxnSpPr>
+        <p:spPr>
+          <a:xfrm>
+            <a:off x="6765988" y="5146067"/>
+            <a:ext cx="0" cy="564624"/>
+          </a:xfrm>
+          <a:prstGeom prst="line">
+            <a:avLst/>
+          </a:prstGeom>
+          <a:ln>
+            <a:solidFill>
+              <a:srgbClr val="FF0000"/>
+            </a:solidFill>
+          </a:ln>
+        </p:spPr>
+        <p:style>
+          <a:lnRef idx="1">
+            <a:schemeClr val="accent1"/>
+          </a:lnRef>
+          <a:fillRef idx="0">
+            <a:schemeClr val="accent1"/>
+          </a:fillRef>
+          <a:effectRef idx="0">
+            <a:schemeClr val="accent1"/>
+          </a:effectRef>
+          <a:fontRef idx="minor">
+            <a:schemeClr val="tx1"/>
+          </a:fontRef>
+        </p:style>
+      </p:cxnSp>
+      <p:cxnSp>
+        <p:nvCxnSpPr>
+          <p:cNvPr id="2057" name="Conector: Angulado 2056">
+            <a:extLst>
+              <a:ext uri="{FF2B5EF4-FFF2-40B4-BE49-F238E27FC236}">
+                <a16:creationId xmlns:a16="http://schemas.microsoft.com/office/drawing/2014/main" id="{7F1E1E2E-2876-4398-AE79-76F4E2F80272}"/>
+              </a:ext>
+            </a:extLst>
+          </p:cNvPr>
+          <p:cNvCxnSpPr>
+            <a:stCxn id="170" idx="2"/>
+            <a:endCxn id="90" idx="0"/>
+          </p:cNvCxnSpPr>
+          <p:nvPr/>
+        </p:nvCxnSpPr>
+        <p:spPr>
+          <a:xfrm rot="16200000" flipH="1">
+            <a:off x="7455597" y="4456457"/>
+            <a:ext cx="564624" cy="1943843"/>
+          </a:xfrm>
+          <a:prstGeom prst="bentConnector3">
+            <a:avLst/>
+          </a:prstGeom>
+          <a:ln>
+            <a:solidFill>
+              <a:srgbClr val="FF0000"/>
+            </a:solidFill>
+          </a:ln>
+        </p:spPr>
+        <p:style>
+          <a:lnRef idx="1">
+            <a:schemeClr val="accent1"/>
+          </a:lnRef>
+          <a:fillRef idx="0">
+            <a:schemeClr val="accent1"/>
+          </a:fillRef>
+          <a:effectRef idx="0">
+            <a:schemeClr val="accent1"/>
+          </a:effectRef>
+          <a:fontRef idx="minor">
+            <a:schemeClr val="tx1"/>
+          </a:fontRef>
+        </p:style>
+      </p:cxnSp>
+      <p:cxnSp>
+        <p:nvCxnSpPr>
+          <p:cNvPr id="2059" name="Conector: Angulado 2058">
+            <a:extLst>
+              <a:ext uri="{FF2B5EF4-FFF2-40B4-BE49-F238E27FC236}">
+                <a16:creationId xmlns:a16="http://schemas.microsoft.com/office/drawing/2014/main" id="{03323079-4A70-4DC7-B145-51FCEB404684}"/>
+              </a:ext>
+            </a:extLst>
+          </p:cNvPr>
+          <p:cNvCxnSpPr>
+            <a:stCxn id="170" idx="2"/>
+            <a:endCxn id="84" idx="0"/>
+          </p:cNvCxnSpPr>
+          <p:nvPr/>
+        </p:nvCxnSpPr>
+        <p:spPr>
+          <a:xfrm rot="5400000">
+            <a:off x="4557033" y="3501736"/>
+            <a:ext cx="564624" cy="3853287"/>
+          </a:xfrm>
+          <a:prstGeom prst="bentConnector3">
+            <a:avLst/>
+          </a:prstGeom>
+          <a:ln>
+            <a:solidFill>
+              <a:srgbClr val="FF0000"/>
+            </a:solidFill>
+          </a:ln>
+        </p:spPr>
+        <p:style>
+          <a:lnRef idx="1">
+            <a:schemeClr val="accent1"/>
+          </a:lnRef>
+          <a:fillRef idx="0">
+            <a:schemeClr val="accent1"/>
+          </a:fillRef>
+          <a:effectRef idx="0">
+            <a:schemeClr val="accent1"/>
+          </a:effectRef>
+          <a:fontRef idx="minor">
+            <a:schemeClr val="tx1"/>
+          </a:fontRef>
+        </p:style>
+      </p:cxnSp>
+      <p:cxnSp>
+        <p:nvCxnSpPr>
+          <p:cNvPr id="2061" name="Conector reto 2060">
+            <a:extLst>
+              <a:ext uri="{FF2B5EF4-FFF2-40B4-BE49-F238E27FC236}">
+                <a16:creationId xmlns:a16="http://schemas.microsoft.com/office/drawing/2014/main" id="{CE820B09-4DC4-4A17-B375-617C9A0CD17D}"/>
+              </a:ext>
+            </a:extLst>
+          </p:cNvPr>
+          <p:cNvCxnSpPr>
+            <a:stCxn id="99" idx="2"/>
+            <a:endCxn id="170" idx="0"/>
+          </p:cNvCxnSpPr>
+          <p:nvPr/>
+        </p:nvCxnSpPr>
+        <p:spPr>
+          <a:xfrm>
+            <a:off x="6765988" y="3805187"/>
+            <a:ext cx="0" cy="992250"/>
+          </a:xfrm>
+          <a:prstGeom prst="line">
+            <a:avLst/>
+          </a:prstGeom>
+          <a:ln>
+            <a:solidFill>
+              <a:srgbClr val="FF0000"/>
+            </a:solidFill>
+          </a:ln>
+        </p:spPr>
+        <p:style>
+          <a:lnRef idx="1">
+            <a:schemeClr val="accent1"/>
+          </a:lnRef>
+          <a:fillRef idx="0">
+            <a:schemeClr val="accent1"/>
+          </a:fillRef>
+          <a:effectRef idx="0">
+            <a:schemeClr val="accent1"/>
+          </a:effectRef>
+          <a:fontRef idx="minor">
+            <a:schemeClr val="tx1"/>
+          </a:fontRef>
+        </p:style>
+      </p:cxnSp>
+      <p:cxnSp>
+        <p:nvCxnSpPr>
+          <p:cNvPr id="2063" name="Conector reto 2062">
+            <a:extLst>
+              <a:ext uri="{FF2B5EF4-FFF2-40B4-BE49-F238E27FC236}">
+                <a16:creationId xmlns:a16="http://schemas.microsoft.com/office/drawing/2014/main" id="{C369E839-5DFB-44EF-9FB7-990C230F7628}"/>
+              </a:ext>
+            </a:extLst>
+          </p:cNvPr>
+          <p:cNvCxnSpPr>
+            <a:cxnSpLocks/>
+            <a:endCxn id="231" idx="3"/>
+          </p:cNvCxnSpPr>
+          <p:nvPr/>
+        </p:nvCxnSpPr>
+        <p:spPr>
+          <a:xfrm flipH="1" flipV="1">
+            <a:off x="5734474" y="2966038"/>
+            <a:ext cx="761578" cy="510588"/>
+          </a:xfrm>
+          <a:prstGeom prst="line">
+            <a:avLst/>
+          </a:prstGeom>
+          <a:ln>
+            <a:solidFill>
+              <a:srgbClr val="FF0000"/>
+            </a:solidFill>
+          </a:ln>
+        </p:spPr>
+        <p:style>
+          <a:lnRef idx="1">
+            <a:schemeClr val="accent1"/>
+          </a:lnRef>
+          <a:fillRef idx="0">
+            <a:schemeClr val="accent1"/>
+          </a:fillRef>
+          <a:effectRef idx="0">
+            <a:schemeClr val="accent1"/>
+          </a:effectRef>
+          <a:fontRef idx="minor">
+            <a:schemeClr val="tx1"/>
+          </a:fontRef>
+        </p:style>
+      </p:cxnSp>
+      <p:cxnSp>
+        <p:nvCxnSpPr>
+          <p:cNvPr id="2067" name="Conector reto 2066">
+            <a:extLst>
+              <a:ext uri="{FF2B5EF4-FFF2-40B4-BE49-F238E27FC236}">
+                <a16:creationId xmlns:a16="http://schemas.microsoft.com/office/drawing/2014/main" id="{9C9DF4EA-12B3-4E21-A866-CB44E57A6AD8}"/>
+              </a:ext>
+            </a:extLst>
+          </p:cNvPr>
+          <p:cNvCxnSpPr>
+            <a:stCxn id="231" idx="0"/>
+            <a:endCxn id="192" idx="2"/>
+          </p:cNvCxnSpPr>
+          <p:nvPr/>
+        </p:nvCxnSpPr>
+        <p:spPr>
+          <a:xfrm flipV="1">
+            <a:off x="5464300" y="2327629"/>
+            <a:ext cx="0" cy="418892"/>
+          </a:xfrm>
+          <a:prstGeom prst="line">
+            <a:avLst/>
+          </a:prstGeom>
+          <a:ln>
+            <a:solidFill>
+              <a:srgbClr val="FF0000"/>
+            </a:solidFill>
+          </a:ln>
+        </p:spPr>
+        <p:style>
+          <a:lnRef idx="1">
+            <a:schemeClr val="accent1"/>
+          </a:lnRef>
+          <a:fillRef idx="0">
+            <a:schemeClr val="accent1"/>
+          </a:fillRef>
+          <a:effectRef idx="0">
+            <a:schemeClr val="accent1"/>
+          </a:effectRef>
+          <a:fontRef idx="minor">
+            <a:schemeClr val="tx1"/>
+          </a:fontRef>
+        </p:style>
+      </p:cxnSp>
+      <p:cxnSp>
+        <p:nvCxnSpPr>
+          <p:cNvPr id="2069" name="Conector reto 2068">
+            <a:extLst>
+              <a:ext uri="{FF2B5EF4-FFF2-40B4-BE49-F238E27FC236}">
+                <a16:creationId xmlns:a16="http://schemas.microsoft.com/office/drawing/2014/main" id="{09754034-CBCF-4457-A96C-2EC91BECD3C2}"/>
+              </a:ext>
+            </a:extLst>
+          </p:cNvPr>
+          <p:cNvCxnSpPr>
+            <a:stCxn id="192" idx="0"/>
+            <a:endCxn id="220" idx="2"/>
+          </p:cNvCxnSpPr>
+          <p:nvPr/>
+        </p:nvCxnSpPr>
+        <p:spPr>
+          <a:xfrm flipV="1">
+            <a:off x="5464300" y="973012"/>
+            <a:ext cx="0" cy="418891"/>
+          </a:xfrm>
+          <a:prstGeom prst="line">
+            <a:avLst/>
+          </a:prstGeom>
+          <a:ln>
+            <a:solidFill>
+              <a:srgbClr val="FF0000"/>
+            </a:solidFill>
+          </a:ln>
+        </p:spPr>
+        <p:style>
+          <a:lnRef idx="1">
+            <a:schemeClr val="accent1"/>
+          </a:lnRef>
+          <a:fillRef idx="0">
+            <a:schemeClr val="accent1"/>
+          </a:fillRef>
+          <a:effectRef idx="0">
+            <a:schemeClr val="accent1"/>
+          </a:effectRef>
+          <a:fontRef idx="minor">
+            <a:schemeClr val="tx1"/>
+          </a:fontRef>
+        </p:style>
+      </p:cxnSp>
+      <p:cxnSp>
+        <p:nvCxnSpPr>
+          <p:cNvPr id="2071" name="Conector reto 2070">
+            <a:extLst>
+              <a:ext uri="{FF2B5EF4-FFF2-40B4-BE49-F238E27FC236}">
+                <a16:creationId xmlns:a16="http://schemas.microsoft.com/office/drawing/2014/main" id="{4321C797-AD70-4E0C-A12F-AB5E8061CAF0}"/>
+              </a:ext>
+            </a:extLst>
+          </p:cNvPr>
+          <p:cNvCxnSpPr>
+            <a:stCxn id="220" idx="3"/>
+            <a:endCxn id="214" idx="7"/>
+          </p:cNvCxnSpPr>
+          <p:nvPr/>
+        </p:nvCxnSpPr>
+        <p:spPr>
+          <a:xfrm flipV="1">
+            <a:off x="5734474" y="594663"/>
+            <a:ext cx="860405" cy="158832"/>
+          </a:xfrm>
+          <a:prstGeom prst="line">
+            <a:avLst/>
+          </a:prstGeom>
+          <a:ln>
+            <a:solidFill>
+              <a:srgbClr val="FF0000"/>
+            </a:solidFill>
+          </a:ln>
+        </p:spPr>
+        <p:style>
+          <a:lnRef idx="1">
+            <a:schemeClr val="accent1"/>
+          </a:lnRef>
+          <a:fillRef idx="0">
+            <a:schemeClr val="accent1"/>
+          </a:fillRef>
+          <a:effectRef idx="0">
+            <a:schemeClr val="accent1"/>
+          </a:effectRef>
+          <a:fontRef idx="minor">
+            <a:schemeClr val="tx1"/>
+          </a:fontRef>
+        </p:style>
+      </p:cxnSp>
+      <p:sp>
+        <p:nvSpPr>
+          <p:cNvPr id="291" name="CaixaDeTexto 290">
+            <a:extLst>
+              <a:ext uri="{FF2B5EF4-FFF2-40B4-BE49-F238E27FC236}">
+                <a16:creationId xmlns:a16="http://schemas.microsoft.com/office/drawing/2014/main" id="{BE5B7E30-48A8-48B2-B9D9-B3950FA97662}"/>
+              </a:ext>
+            </a:extLst>
+          </p:cNvPr>
+          <p:cNvSpPr txBox="1"/>
+          <p:nvPr/>
+        </p:nvSpPr>
+        <p:spPr>
+          <a:xfrm>
+            <a:off x="5500033" y="4803567"/>
+            <a:ext cx="867545" cy="288541"/>
+          </a:xfrm>
+          <a:prstGeom prst="rect">
+            <a:avLst/>
+          </a:prstGeom>
+          <a:noFill/>
+        </p:spPr>
+        <p:txBody>
+          <a:bodyPr wrap="none" rtlCol="0">
+            <a:spAutoFit/>
+          </a:bodyPr>
+          <a:lstStyle/>
+          <a:p>
+            <a:pPr algn="ctr"/>
+            <a:r>
+              <a:rPr lang="pt-BR" sz="1275" spc="0" baseline="0" dirty="0">
+                <a:solidFill>
+                  <a:srgbClr val="00B0F0"/>
+                </a:solidFill>
+                <a:latin typeface="Arial"/>
+                <a:cs typeface="Arial"/>
+                <a:sym typeface="Arial"/>
+                <a:rtl val="0"/>
+              </a:rPr>
+              <a:t>10.10.0.1</a:t>
+            </a:r>
+          </a:p>
+        </p:txBody>
+      </p:sp>
+      <p:sp>
+        <p:nvSpPr>
+          <p:cNvPr id="293" name="CaixaDeTexto 292">
+            <a:extLst>
+              <a:ext uri="{FF2B5EF4-FFF2-40B4-BE49-F238E27FC236}">
+                <a16:creationId xmlns:a16="http://schemas.microsoft.com/office/drawing/2014/main" id="{D27143F2-C3C7-410E-8B5A-511D4931BA9E}"/>
+              </a:ext>
+            </a:extLst>
+          </p:cNvPr>
+          <p:cNvSpPr txBox="1"/>
+          <p:nvPr/>
+        </p:nvSpPr>
+        <p:spPr>
+          <a:xfrm>
+            <a:off x="6514107" y="3091856"/>
+            <a:ext cx="1233031" cy="288541"/>
+          </a:xfrm>
+          <a:prstGeom prst="rect">
+            <a:avLst/>
+          </a:prstGeom>
+          <a:noFill/>
+        </p:spPr>
+        <p:txBody>
+          <a:bodyPr wrap="none" rtlCol="0">
+            <a:spAutoFit/>
+          </a:bodyPr>
+          <a:lstStyle/>
+          <a:p>
+            <a:pPr algn="ctr"/>
+            <a:r>
+              <a:rPr lang="pt-BR" sz="1275" spc="0" baseline="0" dirty="0">
+                <a:solidFill>
+                  <a:srgbClr val="00B0F0"/>
+                </a:solidFill>
+                <a:latin typeface="Arial"/>
+                <a:cs typeface="Arial"/>
+                <a:sym typeface="Arial"/>
+                <a:rtl val="0"/>
+              </a:rPr>
+              <a:t>205.251.193.1</a:t>
+            </a:r>
+          </a:p>
+        </p:txBody>
+      </p:sp>
+      <p:sp>
+        <p:nvSpPr>
+          <p:cNvPr id="295" name="CaixaDeTexto 294">
+            <a:extLst>
+              <a:ext uri="{FF2B5EF4-FFF2-40B4-BE49-F238E27FC236}">
+                <a16:creationId xmlns:a16="http://schemas.microsoft.com/office/drawing/2014/main" id="{A8E5DA4C-31E8-4ACE-81CC-B9BDB0D29512}"/>
+              </a:ext>
+            </a:extLst>
+          </p:cNvPr>
+          <p:cNvSpPr txBox="1"/>
+          <p:nvPr/>
+        </p:nvSpPr>
+        <p:spPr>
+          <a:xfrm>
+            <a:off x="4887244" y="3227973"/>
+            <a:ext cx="1050288" cy="288541"/>
+          </a:xfrm>
+          <a:prstGeom prst="rect">
+            <a:avLst/>
+          </a:prstGeom>
+          <a:noFill/>
+        </p:spPr>
+        <p:txBody>
+          <a:bodyPr wrap="none" rtlCol="0">
+            <a:spAutoFit/>
+          </a:bodyPr>
+          <a:lstStyle/>
+          <a:p>
+            <a:pPr algn="ctr"/>
+            <a:r>
+              <a:rPr lang="pt-BR" sz="1275" spc="0" baseline="0" dirty="0">
+                <a:solidFill>
+                  <a:schemeClr val="accent1"/>
+                </a:solidFill>
+                <a:latin typeface="Arial"/>
+                <a:cs typeface="Arial"/>
+                <a:sym typeface="Arial"/>
+                <a:rtl val="0"/>
+              </a:rPr>
+              <a:t>205.251.1.1</a:t>
+            </a:r>
+          </a:p>
+        </p:txBody>
+      </p:sp>
+      <p:sp>
+        <p:nvSpPr>
+          <p:cNvPr id="297" name="CaixaDeTexto 296">
+            <a:extLst>
+              <a:ext uri="{FF2B5EF4-FFF2-40B4-BE49-F238E27FC236}">
+                <a16:creationId xmlns:a16="http://schemas.microsoft.com/office/drawing/2014/main" id="{11C3DB5B-0D63-4B15-8F86-7DC78A32A73D}"/>
+              </a:ext>
+            </a:extLst>
+          </p:cNvPr>
+          <p:cNvSpPr txBox="1"/>
+          <p:nvPr/>
+        </p:nvSpPr>
+        <p:spPr>
+          <a:xfrm>
+            <a:off x="3281791" y="3096233"/>
+            <a:ext cx="1141659" cy="288541"/>
+          </a:xfrm>
+          <a:prstGeom prst="rect">
+            <a:avLst/>
+          </a:prstGeom>
+          <a:noFill/>
+        </p:spPr>
+        <p:txBody>
+          <a:bodyPr wrap="none" rtlCol="0">
+            <a:spAutoFit/>
+          </a:bodyPr>
+          <a:lstStyle/>
+          <a:p>
+            <a:pPr algn="ctr"/>
+            <a:r>
+              <a:rPr lang="pt-BR" sz="1275" spc="0" baseline="0" dirty="0">
+                <a:solidFill>
+                  <a:srgbClr val="00B0F0"/>
+                </a:solidFill>
+                <a:latin typeface="Arial"/>
+                <a:cs typeface="Arial"/>
+                <a:sym typeface="Arial"/>
+                <a:rtl val="0"/>
+              </a:rPr>
+              <a:t>205.251.10.1</a:t>
+            </a:r>
+          </a:p>
+        </p:txBody>
+      </p:sp>
+      <p:sp>
+        <p:nvSpPr>
+          <p:cNvPr id="299" name="CaixaDeTexto 298">
+            <a:extLst>
+              <a:ext uri="{FF2B5EF4-FFF2-40B4-BE49-F238E27FC236}">
+                <a16:creationId xmlns:a16="http://schemas.microsoft.com/office/drawing/2014/main" id="{213B0DCC-5EB2-44CB-8CAD-038DC26D225B}"/>
+              </a:ext>
+            </a:extLst>
+          </p:cNvPr>
+          <p:cNvSpPr txBox="1"/>
+          <p:nvPr/>
+        </p:nvSpPr>
+        <p:spPr>
+          <a:xfrm>
+            <a:off x="5030526" y="251120"/>
+            <a:ext cx="867545" cy="288541"/>
+          </a:xfrm>
+          <a:prstGeom prst="rect">
+            <a:avLst/>
+          </a:prstGeom>
+          <a:noFill/>
+        </p:spPr>
+        <p:txBody>
+          <a:bodyPr wrap="none" rtlCol="0">
+            <a:spAutoFit/>
+          </a:bodyPr>
+          <a:lstStyle/>
+          <a:p>
+            <a:pPr algn="ctr"/>
+            <a:r>
+              <a:rPr lang="pt-BR" sz="1275" spc="0" baseline="0" dirty="0">
+                <a:solidFill>
+                  <a:schemeClr val="accent1"/>
+                </a:solidFill>
+                <a:latin typeface="Arial"/>
+                <a:cs typeface="Arial"/>
+                <a:sym typeface="Arial"/>
+                <a:rtl val="0"/>
+              </a:rPr>
+              <a:t>205.1.1.1</a:t>
+            </a:r>
+          </a:p>
+        </p:txBody>
+      </p:sp>
+      <p:sp>
+        <p:nvSpPr>
+          <p:cNvPr id="2081" name="Retângulo 2080">
+            <a:extLst>
+              <a:ext uri="{FF2B5EF4-FFF2-40B4-BE49-F238E27FC236}">
+                <a16:creationId xmlns:a16="http://schemas.microsoft.com/office/drawing/2014/main" id="{3A299E4D-9961-455D-9305-F5150C231FC8}"/>
+              </a:ext>
+            </a:extLst>
+          </p:cNvPr>
+          <p:cNvSpPr/>
+          <p:nvPr/>
+        </p:nvSpPr>
+        <p:spPr>
+          <a:xfrm>
+            <a:off x="166778" y="1962601"/>
+            <a:ext cx="4488771" cy="3013685"/>
+          </a:xfrm>
+          <a:prstGeom prst="rect">
+            <a:avLst/>
+          </a:prstGeom>
+          <a:noFill/>
+          <a:ln w="25400">
+            <a:solidFill>
+              <a:schemeClr val="tx1"/>
+            </a:solidFill>
+            <a:prstDash val="sysDash"/>
+          </a:ln>
+        </p:spPr>
+        <p:style>
+          <a:lnRef idx="2">
+            <a:schemeClr val="accent1">
+              <a:shade val="50000"/>
+            </a:schemeClr>
+          </a:lnRef>
+          <a:fillRef idx="1">
+            <a:schemeClr val="accent1"/>
+          </a:fillRef>
+          <a:effectRef idx="0">
+            <a:schemeClr val="accent1"/>
+          </a:effectRef>
+          <a:fontRef idx="minor">
+            <a:schemeClr val="lt1"/>
+          </a:fontRef>
+        </p:style>
+        <p:txBody>
+          <a:bodyPr rtlCol="0" anchor="ctr"/>
+          <a:lstStyle/>
+          <a:p>
+            <a:pPr algn="ctr"/>
+            <a:endParaRPr lang="pt-BR"/>
+          </a:p>
+        </p:txBody>
+      </p:sp>
+      <p:sp>
+        <p:nvSpPr>
+          <p:cNvPr id="2082" name="CaixaDeTexto 2081">
+            <a:extLst>
+              <a:ext uri="{FF2B5EF4-FFF2-40B4-BE49-F238E27FC236}">
+                <a16:creationId xmlns:a16="http://schemas.microsoft.com/office/drawing/2014/main" id="{56306C55-3BF6-447A-9D4C-2C8E80F31667}"/>
+              </a:ext>
+            </a:extLst>
+          </p:cNvPr>
+          <p:cNvSpPr txBox="1"/>
+          <p:nvPr/>
+        </p:nvSpPr>
+        <p:spPr>
+          <a:xfrm>
+            <a:off x="166778" y="1512383"/>
+            <a:ext cx="1551013" cy="369332"/>
+          </a:xfrm>
+          <a:prstGeom prst="rect">
+            <a:avLst/>
+          </a:prstGeom>
+          <a:noFill/>
+        </p:spPr>
+        <p:txBody>
+          <a:bodyPr wrap="square" rtlCol="0">
+            <a:spAutoFit/>
+          </a:bodyPr>
+          <a:lstStyle/>
+          <a:p>
+            <a:r>
+              <a:rPr lang="pt-BR" dirty="0">
+                <a:latin typeface="Arial" panose="020B0604020202020204" pitchFamily="34" charset="0"/>
+                <a:cs typeface="Arial" panose="020B0604020202020204" pitchFamily="34" charset="0"/>
+              </a:rPr>
+              <a:t>EXTRANET</a:t>
+            </a:r>
+          </a:p>
+        </p:txBody>
+      </p:sp>
+      <p:sp>
+        <p:nvSpPr>
+          <p:cNvPr id="337" name="Forma Livre: Forma 336">
+            <a:extLst>
+              <a:ext uri="{FF2B5EF4-FFF2-40B4-BE49-F238E27FC236}">
+                <a16:creationId xmlns:a16="http://schemas.microsoft.com/office/drawing/2014/main" id="{FBE4344E-BCC5-43D3-ABD3-FB20A1DE2818}"/>
+              </a:ext>
+            </a:extLst>
+          </p:cNvPr>
+          <p:cNvSpPr/>
+          <p:nvPr/>
+        </p:nvSpPr>
+        <p:spPr>
+          <a:xfrm>
+            <a:off x="1717788" y="950125"/>
+            <a:ext cx="9406236" cy="5823802"/>
+          </a:xfrm>
+          <a:custGeom>
+            <a:avLst/>
+            <a:gdLst>
+              <a:gd name="connsiteX0" fmla="*/ 6077264 w 9406236"/>
+              <a:gd name="connsiteY0" fmla="*/ 0 h 5823802"/>
+              <a:gd name="connsiteX1" fmla="*/ 9406236 w 9406236"/>
+              <a:gd name="connsiteY1" fmla="*/ 0 h 5823802"/>
+              <a:gd name="connsiteX2" fmla="*/ 9406236 w 9406236"/>
+              <a:gd name="connsiteY2" fmla="*/ 4371739 h 5823802"/>
+              <a:gd name="connsiteX3" fmla="*/ 9406235 w 9406236"/>
+              <a:gd name="connsiteY3" fmla="*/ 4371739 h 5823802"/>
+              <a:gd name="connsiteX4" fmla="*/ 9406235 w 9406236"/>
+              <a:gd name="connsiteY4" fmla="*/ 5823802 h 5823802"/>
+              <a:gd name="connsiteX5" fmla="*/ 0 w 9406236"/>
+              <a:gd name="connsiteY5" fmla="*/ 5823802 h 5823802"/>
+              <a:gd name="connsiteX6" fmla="*/ 0 w 9406236"/>
+              <a:gd name="connsiteY6" fmla="*/ 4195941 h 5823802"/>
+              <a:gd name="connsiteX7" fmla="*/ 3325315 w 9406236"/>
+              <a:gd name="connsiteY7" fmla="*/ 4195941 h 5823802"/>
+              <a:gd name="connsiteX8" fmla="*/ 3325315 w 9406236"/>
+              <a:gd name="connsiteY8" fmla="*/ 3007777 h 5823802"/>
+              <a:gd name="connsiteX9" fmla="*/ 4593994 w 9406236"/>
+              <a:gd name="connsiteY9" fmla="*/ 3007777 h 5823802"/>
+              <a:gd name="connsiteX10" fmla="*/ 4593994 w 9406236"/>
+              <a:gd name="connsiteY10" fmla="*/ 1912360 h 5823802"/>
+              <a:gd name="connsiteX11" fmla="*/ 6077264 w 9406236"/>
+              <a:gd name="connsiteY11" fmla="*/ 1912360 h 5823802"/>
+            </a:gdLst>
+            <a:ahLst/>
+            <a:cxnLst>
+              <a:cxn ang="0">
+                <a:pos x="connsiteX0" y="connsiteY0"/>
+              </a:cxn>
+              <a:cxn ang="0">
+                <a:pos x="connsiteX1" y="connsiteY1"/>
+              </a:cxn>
+              <a:cxn ang="0">
+                <a:pos x="connsiteX2" y="connsiteY2"/>
+              </a:cxn>
+              <a:cxn ang="0">
+                <a:pos x="connsiteX3" y="connsiteY3"/>
+              </a:cxn>
+              <a:cxn ang="0">
+                <a:pos x="connsiteX4" y="connsiteY4"/>
+              </a:cxn>
+              <a:cxn ang="0">
+                <a:pos x="connsiteX5" y="connsiteY5"/>
+              </a:cxn>
+              <a:cxn ang="0">
+                <a:pos x="connsiteX6" y="connsiteY6"/>
+              </a:cxn>
+              <a:cxn ang="0">
+                <a:pos x="connsiteX7" y="connsiteY7"/>
+              </a:cxn>
+              <a:cxn ang="0">
+                <a:pos x="connsiteX8" y="connsiteY8"/>
+              </a:cxn>
+              <a:cxn ang="0">
+                <a:pos x="connsiteX9" y="connsiteY9"/>
+              </a:cxn>
+              <a:cxn ang="0">
+                <a:pos x="connsiteX10" y="connsiteY10"/>
+              </a:cxn>
+              <a:cxn ang="0">
+                <a:pos x="connsiteX11" y="connsiteY11"/>
+              </a:cxn>
+            </a:cxnLst>
+            <a:rect l="l" t="t" r="r" b="b"/>
+            <a:pathLst>
+              <a:path w="9406236" h="5823802">
+                <a:moveTo>
+                  <a:pt x="6077264" y="0"/>
+                </a:moveTo>
+                <a:lnTo>
+                  <a:pt x="9406236" y="0"/>
+                </a:lnTo>
+                <a:lnTo>
+                  <a:pt x="9406236" y="4371739"/>
+                </a:lnTo>
+                <a:lnTo>
+                  <a:pt x="9406235" y="4371739"/>
+                </a:lnTo>
+                <a:lnTo>
+                  <a:pt x="9406235" y="5823802"/>
+                </a:lnTo>
+                <a:lnTo>
+                  <a:pt x="0" y="5823802"/>
+                </a:lnTo>
+                <a:lnTo>
+                  <a:pt x="0" y="4195941"/>
+                </a:lnTo>
+                <a:lnTo>
+                  <a:pt x="3325315" y="4195941"/>
+                </a:lnTo>
+                <a:lnTo>
+                  <a:pt x="3325315" y="3007777"/>
+                </a:lnTo>
+                <a:lnTo>
+                  <a:pt x="4593994" y="3007777"/>
+                </a:lnTo>
+                <a:lnTo>
+                  <a:pt x="4593994" y="1912360"/>
+                </a:lnTo>
+                <a:lnTo>
+                  <a:pt x="6077264" y="1912360"/>
+                </a:lnTo>
+                <a:close/>
+              </a:path>
+            </a:pathLst>
+          </a:custGeom>
+          <a:noFill/>
+          <a:ln w="25400">
+            <a:solidFill>
+              <a:srgbClr val="00B050"/>
+            </a:solidFill>
+            <a:prstDash val="sysDash"/>
+          </a:ln>
+        </p:spPr>
+        <p:style>
+          <a:lnRef idx="2">
+            <a:schemeClr val="accent1">
+              <a:shade val="50000"/>
+            </a:schemeClr>
+          </a:lnRef>
+          <a:fillRef idx="1">
+            <a:schemeClr val="accent1"/>
+          </a:fillRef>
+          <a:effectRef idx="0">
+            <a:schemeClr val="accent1"/>
+          </a:effectRef>
+          <a:fontRef idx="minor">
+            <a:schemeClr val="lt1"/>
+          </a:fontRef>
+        </p:style>
+        <p:txBody>
+          <a:bodyPr wrap="square" rtlCol="0" anchor="ctr">
+            <a:noAutofit/>
+          </a:bodyPr>
+          <a:lstStyle/>
+          <a:p>
+            <a:pPr algn="ctr"/>
+            <a:endParaRPr lang="pt-BR"/>
+          </a:p>
+        </p:txBody>
+      </p:sp>
+      <p:sp>
+        <p:nvSpPr>
+          <p:cNvPr id="338" name="CaixaDeTexto 337">
+            <a:extLst>
+              <a:ext uri="{FF2B5EF4-FFF2-40B4-BE49-F238E27FC236}">
+                <a16:creationId xmlns:a16="http://schemas.microsoft.com/office/drawing/2014/main" id="{8852E888-D68F-4D81-A101-CF4CAAB187BD}"/>
+              </a:ext>
+            </a:extLst>
+          </p:cNvPr>
+          <p:cNvSpPr txBox="1"/>
+          <p:nvPr/>
+        </p:nvSpPr>
+        <p:spPr>
+          <a:xfrm>
+            <a:off x="9678457" y="548761"/>
+            <a:ext cx="1445568" cy="369332"/>
+          </a:xfrm>
+          <a:prstGeom prst="rect">
+            <a:avLst/>
+          </a:prstGeom>
+          <a:noFill/>
+        </p:spPr>
+        <p:txBody>
+          <a:bodyPr wrap="square" rtlCol="0">
+            <a:spAutoFit/>
+          </a:bodyPr>
+          <a:lstStyle/>
+          <a:p>
+            <a:pPr algn="r"/>
+            <a:r>
+              <a:rPr lang="pt-BR" dirty="0">
+                <a:solidFill>
+                  <a:srgbClr val="00B050"/>
+                </a:solidFill>
+                <a:latin typeface="Arial" panose="020B0604020202020204" pitchFamily="34" charset="0"/>
+                <a:cs typeface="Arial" panose="020B0604020202020204" pitchFamily="34" charset="0"/>
+              </a:rPr>
+              <a:t>INTRANET</a:t>
+            </a:r>
+          </a:p>
+        </p:txBody>
+      </p:sp>
+      <p:sp>
+        <p:nvSpPr>
+          <p:cNvPr id="85" name="CaixaDeTexto 84">
+            <a:extLst>
+              <a:ext uri="{FF2B5EF4-FFF2-40B4-BE49-F238E27FC236}">
+                <a16:creationId xmlns:a16="http://schemas.microsoft.com/office/drawing/2014/main" id="{AA80ACB1-AEBD-479A-BF09-9068E06D5F05}"/>
+              </a:ext>
+            </a:extLst>
+          </p:cNvPr>
+          <p:cNvSpPr txBox="1"/>
+          <p:nvPr/>
+        </p:nvSpPr>
+        <p:spPr>
+          <a:xfrm>
+            <a:off x="4153715" y="1468790"/>
+            <a:ext cx="1050288" cy="288541"/>
+          </a:xfrm>
+          <a:prstGeom prst="rect">
+            <a:avLst/>
+          </a:prstGeom>
+          <a:noFill/>
+        </p:spPr>
+        <p:txBody>
+          <a:bodyPr wrap="none" rtlCol="0">
+            <a:spAutoFit/>
+          </a:bodyPr>
+          <a:lstStyle/>
+          <a:p>
+            <a:pPr algn="ctr"/>
+            <a:r>
+              <a:rPr lang="pt-BR" sz="1275" dirty="0">
+                <a:solidFill>
+                  <a:srgbClr val="740000"/>
+                </a:solidFill>
+                <a:latin typeface="Arial"/>
+                <a:cs typeface="Arial"/>
+                <a:sym typeface="Arial"/>
+                <a:rtl val="0"/>
+              </a:rPr>
+              <a:t>205.1.1.100</a:t>
+            </a:r>
+          </a:p>
+        </p:txBody>
+      </p:sp>
+    </p:spTree>
+    <p:extLst>
+      <p:ext uri="{BB962C8B-B14F-4D97-AF65-F5344CB8AC3E}">
+        <p14:creationId xmlns:p14="http://schemas.microsoft.com/office/powerpoint/2010/main" val="2800403317"/>
       </p:ext>
     </p:extLst>
   </p:cSld>

</xml_diff>